<commit_message>
Thiết kế lại 4 bản slide kiểu đại học: hệ thống thiết kế dùng chung, icon, thẻ số liệu, bảng, biểu đồ
Co-Authored-By: Claude Sonnet 5.5 <noreply@anthropic.com>
Claude-Session: https://claude.ai/code/session_01T37v9MbVMU9yXHRJ84QwZj
</commit_message>
<xml_diff>
--- a/tests/outputs/bao-cao-tong-ket-nam-truong.pptx
+++ b/tests/outputs/bao-cao-tong-ket-nam-truong.pptx
@@ -14,9 +14,10 @@
     <p:sldId id="262" r:id="rId8"/>
     <p:sldId id="263" r:id="rId9"/>
     <p:sldId id="264" r:id="rId10"/>
+    <p:sldId id="265" r:id="rId11"/>
   </p:sldIdLst>
   <p:notesMasterIdLst>
-    <p:notesMasterId r:id="rId11"/>
+    <p:notesMasterId r:id="rId12"/>
   </p:notesMasterIdLst>
   <p:sldSz cx="9144000" cy="5143500"/>
   <p:notesSz cx="5143500" cy="9144000"/>
@@ -115,25 +116,34 @@
   <p:extLst>
     <p:ext uri="{521415D9-36F7-43E2-AB2F-B90AF26B5E84}">
       <p14:sectionLst xmlns:p14="http://schemas.microsoft.com/office/powerpoint/2010/main">
-        <p14:section name="Mở đầu" id="{bc029620-b5cb-c96a-cd5f-8d7ff8a97bbd}">
+        <p14:section name="Mở đầu" id="{8214f276-581f-5334-8764-978f1b43d756}">
           <p14:sldIdLst>
             <p14:sldId id="256"/>
+            <p14:sldId id="257"/>
           </p14:sldIdLst>
         </p14:section>
-        <p14:section name="Kết quả" id="{2c0d4822-922d-0e47-3795-6ecd0d3fce4d}">
+        <p14:section name="Kết quả" id="{accaeae4-1173-37be-7ad1-ed65a2a64a87}">
           <p14:sldIdLst>
-            <p14:sldId id="257"/>
             <p14:sldId id="258"/>
+          </p14:sldIdLst>
+        </p14:section>
+        <p14:section name="Đào tạo" id="{3e92d090-bf84-dce8-8f25-b71f555c1192}">
+          <p14:sldIdLst>
             <p14:sldId id="259"/>
             <p14:sldId id="260"/>
-            <p14:sldId id="261"/>
           </p14:sldIdLst>
         </p14:section>
-        <p14:section name="Tồn tại và phương hướng" id="{a2e38413-f463-84cd-b1de-ba9eab551203}">
+        <p14:section name="Tài chính" id="{0cf71c01-6c01-4f19-6309-a142de3c6ced}">
           <p14:sldIdLst>
+            <p14:sldId id="261"/>
             <p14:sldId id="262"/>
+          </p14:sldIdLst>
+        </p14:section>
+        <p14:section name="Tồn tại và phương hướng" id="{2749ee25-b8ba-0329-b38f-b58d09c4d5bb}">
+          <p14:sldIdLst>
             <p14:sldId id="263"/>
             <p14:sldId id="264"/>
+            <p14:sldId id="265"/>
           </p14:sldIdLst>
         </p14:section>
       </p14:sectionLst>
@@ -173,7 +183,7 @@
           </c:tx>
           <c:spPr>
             <a:solidFill>
-              <a:srgbClr val="B8C4C3"/>
+              <a:srgbClr val="B7C3D4"/>
             </a:solidFill>
             <a:effectLst/>
           </c:spPr>
@@ -187,7 +197,7 @@
                 <a:pPr>
                   <a:defRPr b="0" i="0" strike="noStrike" sz="1200" u="none">
                     <a:solidFill>
-                      <a:srgbClr val="1B1F2A"/>
+                      <a:srgbClr val="1A2433"/>
                     </a:solidFill>
                     <a:latin typeface="Arial"/>
                   </a:defRPr>
@@ -262,7 +272,7 @@
           </c:tx>
           <c:spPr>
             <a:solidFill>
-              <a:srgbClr val="0F6E6E"/>
+              <a:srgbClr val="1F4E8C"/>
             </a:solidFill>
             <a:effectLst/>
           </c:spPr>
@@ -276,7 +286,7 @@
                 <a:pPr>
                   <a:defRPr b="0" i="0" strike="noStrike" sz="1200" u="none">
                     <a:solidFill>
-                      <a:srgbClr val="1B1F2A"/>
+                      <a:srgbClr val="1A2433"/>
                     </a:solidFill>
                     <a:latin typeface="Arial"/>
                   </a:defRPr>
@@ -344,7 +354,7 @@
               <a:pPr>
                 <a:defRPr b="0" i="0" strike="noStrike" sz="1200" u="none">
                   <a:solidFill>
-                    <a:srgbClr val="1B1F2A"/>
+                    <a:srgbClr val="1A2433"/>
                   </a:solidFill>
                   <a:latin typeface="Arial"/>
                 </a:defRPr>
@@ -392,7 +402,7 @@
             <a:pPr>
               <a:defRPr sz="1200" b="0" i="0" u="none" strike="noStrike">
                 <a:solidFill>
-                  <a:srgbClr val="1B1F2A"/>
+                  <a:srgbClr val="1A2433"/>
                 </a:solidFill>
                 <a:latin typeface="Arial"/>
               </a:defRPr>
@@ -418,7 +428,7 @@
           <c:spPr>
             <a:ln w="6350" cap="flat">
               <a:solidFill>
-                <a:srgbClr val="D9E0DF"/>
+                <a:srgbClr val="E3E8EF"/>
               </a:solidFill>
               <a:prstDash val="solid"/>
               <a:round/>
@@ -472,7 +482,7 @@
             <a:pPr>
               <a:defRPr sz="1200" b="0" i="0" u="none" strike="noStrike">
                 <a:solidFill>
-                  <a:srgbClr val="1B1F2A"/>
+                  <a:srgbClr val="1A2433"/>
                 </a:solidFill>
                 <a:latin typeface="Arial"/>
               </a:defRPr>
@@ -548,11 +558,11 @@
           </c:tx>
           <c:spPr>
             <a:solidFill>
-              <a:srgbClr val="0F6E6E"/>
+              <a:srgbClr val="1F4E8C"/>
             </a:solidFill>
             <a:ln w="38100" cap="flat">
               <a:solidFill>
-                <a:srgbClr val="0F6E6E"/>
+                <a:srgbClr val="1F4E8C"/>
               </a:solidFill>
               <a:prstDash val="solid"/>
               <a:round/>
@@ -569,7 +579,7 @@
                 <a:pPr>
                   <a:defRPr b="0" i="0" strike="noStrike" sz="1200" u="none">
                     <a:solidFill>
-                      <a:srgbClr val="1B1F2A"/>
+                      <a:srgbClr val="1A2433"/>
                     </a:solidFill>
                     <a:latin typeface="Arial"/>
                   </a:defRPr>
@@ -589,11 +599,11 @@
             <c:size val="9"/>
             <c:spPr>
               <a:solidFill>
-                <a:srgbClr val="0F6E6E"/>
+                <a:srgbClr val="1F4E8C"/>
               </a:solidFill>
               <a:ln w="9525" cap="flat">
                 <a:solidFill>
-                  <a:srgbClr val="0F6E6E"/>
+                  <a:srgbClr val="1F4E8C"/>
                 </a:solidFill>
                 <a:prstDash val="solid"/>
                 <a:round/>
@@ -649,7 +659,7 @@
               <a:pPr>
                 <a:defRPr b="0" i="0" strike="noStrike" sz="1200" u="none">
                   <a:solidFill>
-                    <a:srgbClr val="1B1F2A"/>
+                    <a:srgbClr val="1A2433"/>
                   </a:solidFill>
                   <a:latin typeface="Arial"/>
                 </a:defRPr>
@@ -696,7 +706,7 @@
             <a:pPr>
               <a:defRPr sz="1200" b="0" i="0" u="none" strike="noStrike">
                 <a:solidFill>
-                  <a:srgbClr val="1B1F2A"/>
+                  <a:srgbClr val="1A2433"/>
                 </a:solidFill>
                 <a:latin typeface="Arial"/>
               </a:defRPr>
@@ -723,7 +733,7 @@
           <c:spPr>
             <a:ln w="6350" cap="flat">
               <a:solidFill>
-                <a:srgbClr val="D9E0DF"/>
+                <a:srgbClr val="E3E8EF"/>
               </a:solidFill>
               <a:prstDash val="solid"/>
               <a:round/>
@@ -777,7 +787,7 @@
             <a:pPr>
               <a:defRPr sz="1200" b="0" i="0" u="none" strike="noStrike">
                 <a:solidFill>
-                  <a:srgbClr val="1B1F2A"/>
+                  <a:srgbClr val="1A2433"/>
                 </a:solidFill>
                 <a:latin typeface="Arial"/>
               </a:defRPr>
@@ -841,7 +851,7 @@
           </c:tx>
           <c:spPr>
             <a:solidFill>
-              <a:srgbClr val="0F6E6E"/>
+              <a:srgbClr val="1F4E8C"/>
             </a:solidFill>
             <a:effectLst/>
           </c:spPr>
@@ -855,7 +865,7 @@
                 <a:pPr>
                   <a:defRPr b="0" i="0" strike="noStrike" sz="1200" u="none">
                     <a:solidFill>
-                      <a:srgbClr val="1B1F2A"/>
+                      <a:srgbClr val="1A2433"/>
                     </a:solidFill>
                     <a:latin typeface="Arial"/>
                   </a:defRPr>
@@ -923,7 +933,7 @@
               <a:pPr>
                 <a:defRPr b="0" i="0" strike="noStrike" sz="1200" u="none">
                   <a:solidFill>
-                    <a:srgbClr val="1B1F2A"/>
+                    <a:srgbClr val="1A2433"/>
                   </a:solidFill>
                   <a:latin typeface="Arial"/>
                 </a:defRPr>
@@ -971,7 +981,7 @@
             <a:pPr>
               <a:defRPr sz="1200" b="0" i="0" u="none" strike="noStrike">
                 <a:solidFill>
-                  <a:srgbClr val="1B1F2A"/>
+                  <a:srgbClr val="1A2433"/>
                 </a:solidFill>
                 <a:latin typeface="Arial"/>
               </a:defRPr>
@@ -997,7 +1007,7 @@
           <c:spPr>
             <a:ln w="6350" cap="flat">
               <a:solidFill>
-                <a:srgbClr val="D9E0DF"/>
+                <a:srgbClr val="E3E8EF"/>
               </a:solidFill>
               <a:prstDash val="solid"/>
               <a:round/>
@@ -1051,7 +1061,7 @@
             <a:pPr>
               <a:defRPr sz="1200" b="0" i="0" u="none" strike="noStrike">
                 <a:solidFill>
-                  <a:srgbClr val="1B1F2A"/>
+                  <a:srgbClr val="1A2433"/>
                 </a:solidFill>
                 <a:latin typeface="Arial"/>
               </a:defRPr>
@@ -1482,7 +1492,7 @@
           <a:p>
             <a:r>
               <a:rPr lang="en-US" dirty="0"/>
-              <a:t>Mở đầu: nêu phạm vi báo cáo gồm đào tạo, tài chính, tồn tại và phương hướng. Báo cáo của Phòng Công tác sinh viên chưa nhận được nên phần này chưa trình bày.</a:t>
+              <a:t>Mở đầu: nêu phạm vi báo cáo gồm đào tạo, tài chính, tồn tại và phương hướng. Báo cáo của Phòng Công tác sinh viên chưa nhận được nên phần này chưa trình bày số liệu.</a:t>
             </a:r>
             <a:endParaRPr lang="en-US" dirty="0"/>
           </a:p>
@@ -1506,6 +1516,94 @@
             <a:fld id="{F7021451-1387-4CA6-816F-3879F97B5CBC}" type="slidenum">
               <a:rPr lang="en-US"/>
               <a:t>1</a:t>
+            </a:fld>
+            <a:endParaRPr lang="en-US"/>
+          </a:p>
+        </p:txBody>
+      </p:sp>
+    </p:spTree>
+    <p:extLst>
+      <p:ext uri="{BB962C8B-B14F-4D97-AF65-F5344CB8AC3E}">
+        <p14:creationId xmlns:p14="http://schemas.microsoft.com/office/powerpoint/2010/main" val="1024086991"/>
+      </p:ext>
+    </p:extLst>
+  </p:cSld>
+  <p:clrMapOvr>
+    <a:masterClrMapping/>
+  </p:clrMapOvr>
+</p:notes>
+</file>
+
+<file path=ppt/notesSlides/notesSlide10.xml><?xml version="1.0" encoding="utf-8"?>
+<p:notes xmlns:a="http://schemas.openxmlformats.org/drawingml/2006/main" xmlns:r="http://schemas.openxmlformats.org/officeDocument/2006/relationships" xmlns:p="http://schemas.openxmlformats.org/presentationml/2006/main">
+  <p:cSld>
+    <p:spTree>
+      <p:nvGrpSpPr>
+        <p:cNvPr id="1" name=""/>
+        <p:cNvGrpSpPr/>
+        <p:nvPr/>
+      </p:nvGrpSpPr>
+      <p:grpSpPr>
+        <a:xfrm>
+          <a:off x="0" y="0"/>
+          <a:ext cx="0" cy="0"/>
+          <a:chOff x="0" y="0"/>
+          <a:chExt cx="0" cy="0"/>
+        </a:xfrm>
+      </p:grpSpPr>
+      <p:sp>
+        <p:nvSpPr>
+          <p:cNvPr id="2" name="Slide Image Placeholder 1"/>
+          <p:cNvSpPr>
+            <a:spLocks noGrp="1" noRot="1" noChangeAspect="1"/>
+          </p:cNvSpPr>
+          <p:nvPr>
+            <p:ph type="sldImg"/>
+          </p:nvPr>
+        </p:nvSpPr>
+        <p:spPr/>
+      </p:sp>
+      <p:sp>
+        <p:nvSpPr>
+          <p:cNvPr id="3" name="Notes Placeholder 2"/>
+          <p:cNvSpPr>
+            <a:spLocks noGrp="1"/>
+          </p:cNvSpPr>
+          <p:nvPr>
+            <p:ph type="body" idx="1"/>
+          </p:nvPr>
+        </p:nvSpPr>
+        <p:spPr/>
+        <p:txBody>
+          <a:bodyPr/>
+          <a:lstStyle/>
+          <a:p>
+            <a:r>
+              <a:rPr lang="en-US" dirty="0"/>
+              <a:t>Kết thúc phần trình bày. Dành thời gian cho các đơn vị góp ý, ghi nhận các ý kiến để bổ sung báo cáo công tác sinh viên và rà lại số liệu chi.</a:t>
+            </a:r>
+            <a:endParaRPr lang="en-US" dirty="0"/>
+          </a:p>
+        </p:txBody>
+      </p:sp>
+      <p:sp>
+        <p:nvSpPr>
+          <p:cNvPr id="4" name="Slide Number Placeholder 3"/>
+          <p:cNvSpPr>
+            <a:spLocks noGrp="1"/>
+          </p:cNvSpPr>
+          <p:nvPr>
+            <p:ph type="sldNum" sz="quarter" idx="10"/>
+          </p:nvPr>
+        </p:nvSpPr>
+        <p:spPr/>
+        <p:txBody>
+          <a:bodyPr/>
+          <a:lstStyle/>
+          <a:p>
+            <a:fld id="{F7021451-1387-4CA6-816F-3879F97B5CBC}" type="slidenum">
+              <a:rPr lang="en-US"/>
+              <a:t>10</a:t>
             </a:fld>
             <a:endParaRPr lang="en-US"/>
           </a:p>
@@ -1570,7 +1668,7 @@
           <a:p>
             <a:r>
               <a:rPr lang="en-US" dirty="0"/>
-              <a:t>Ba con số cần nhớ: tỷ lệ nhập học theo chỉ tiêu, tỷ lệ tốt nghiệp đúng hạn năm gần nhất có số liệu, và tổng thu. Mọi số lấy từ báo cáo các đơn vị.</a:t>
+              <a:t>Bốn phần: kết quả chính, đào tạo, tài chính, tồn tại và phương hướng. Công tác sinh viên sẽ bổ sung khi có báo cáo.</a:t>
             </a:r>
             <a:endParaRPr lang="en-US" dirty="0"/>
           </a:p>
@@ -1658,7 +1756,7 @@
           <a:p>
             <a:r>
               <a:rPr lang="en-US" dirty="0"/>
-              <a:t>So sánh chỉ tiêu và nhập học theo ngành. Luật đạt 85,7%, Ngoại ngữ 88,0%, Kinh tế 92,4%, Công nghệ thông tin 95,2%.</a:t>
+              <a:t>Ba con số cần nhớ: tỷ lệ nhập học theo chỉ tiêu, tỷ lệ tốt nghiệp đúng hạn năm gần nhất có số liệu, và tổng thu. Mọi số lấy từ báo cáo các đơn vị.</a:t>
             </a:r>
             <a:endParaRPr lang="en-US" dirty="0"/>
           </a:p>
@@ -1746,7 +1844,7 @@
           <a:p>
             <a:r>
               <a:rPr lang="en-US" dirty="0"/>
-              <a:t>Từ 78% lên 84%. Lưu ý: nhận xét trong đầu vào nêu chênh lệch 8 điểm, nhưng tính lại 84 trừ 78 là 6 điểm; slide dùng số tính lại. Năm học 2025–2026 chưa xét tốt nghiệp nên chưa có số liệu, không ghi 0.</a:t>
+              <a:t>So sánh chỉ tiêu và nhập học theo ngành. Luật đạt 85,7%, Ngoại ngữ 88,0%, Kinh tế 92,4%, Công nghệ thông tin 95,2%.</a:t>
             </a:r>
             <a:endParaRPr lang="en-US" dirty="0"/>
           </a:p>
@@ -1834,7 +1932,7 @@
           <a:p>
             <a:r>
               <a:rPr lang="en-US" dirty="0"/>
-              <a:t>Cơ cấu chi theo nhóm, đơn vị triệu đồng. Tổng các nhóm là 398.500 triệu đồng, trong khi báo cáo khai tổng chi 400.000 triệu đồng; chênh 1.500 triệu đồng chưa giải thích, đề nghị Phòng Kế hoạch – Tài chính rà lại trước hội nghị.</a:t>
+              <a:t>Từ 78% lên 84%. Lưu ý: nhận xét trong đầu vào nêu chênh lệch 8 điểm, nhưng tính lại 84 trừ 78 là 6 điểm; slide dùng số tính lại. Năm học 2025–2026 chưa xét tốt nghiệp nên chưa có số liệu, không ghi 0.</a:t>
             </a:r>
             <a:endParaRPr lang="en-US" dirty="0"/>
           </a:p>
@@ -1922,7 +2020,7 @@
           <a:p>
             <a:r>
               <a:rPr lang="en-US" dirty="0"/>
-              <a:t>Phòng Công tác sinh viên chưa gửi báo cáo, nên slide này chưa có nội dung. Không điền số liệu thay đơn vị; cập nhật khi nhận được.</a:t>
+              <a:t>Cơ cấu chi theo nhóm, đơn vị triệu đồng. Tổng các nhóm là 398.500 triệu đồng, trong khi báo cáo khai tổng chi 400.000 triệu đồng; chênh 1.500 triệu đồng chưa giải thích, đề nghị Phòng Kế hoạch – Tài chính rà lại trước hội nghị.</a:t>
             </a:r>
             <a:endParaRPr lang="en-US" dirty="0"/>
           </a:p>
@@ -2010,7 +2108,7 @@
           <a:p>
             <a:r>
               <a:rPr lang="en-US" dirty="0"/>
-              <a:t>Mỗi tồn tại đi kèm nguyên nhân do đơn vị nêu. Trình bày thẳng, không giảm nhẹ.</a:t>
+              <a:t>Phòng Công tác sinh viên chưa gửi báo cáo, nên slide này chưa có nội dung. Không điền số liệu thay đơn vị; cập nhật khi nhận được.</a:t>
             </a:r>
             <a:endParaRPr lang="en-US" dirty="0"/>
           </a:p>
@@ -2098,7 +2196,7 @@
           <a:p>
             <a:r>
               <a:rPr lang="en-US" dirty="0"/>
-              <a:t>Đầu vào không có định hướng chung của Ban Giám hiệu, nên chưa nêu chỉ tiêu hay giải pháp mới. Chỉ ghi các việc hiển nhiên từ tồn tại; cập nhật khi có chỉ đạo.</a:t>
+              <a:t>Mỗi tồn tại đi kèm nguyên nhân do đơn vị nêu. Trình bày thẳng, không giảm nhẹ.</a:t>
             </a:r>
             <a:endParaRPr lang="en-US" dirty="0"/>
           </a:p>
@@ -2186,7 +2284,7 @@
           <a:p>
             <a:r>
               <a:rPr lang="en-US" dirty="0"/>
-              <a:t>Kết thúc phần trình bày. Dành thời gian cho các đơn vị góp ý, ghi nhận các ý kiến để bổ sung báo cáo công tác sinh viên và rà lại số liệu chi.</a:t>
+              <a:t>Đầu vào không có định hướng chung của Ban Giám hiệu, nên chưa nêu chỉ tiêu hay giải pháp mới. Chỉ ghi các việc hiển nhiên từ tồn tại; cập nhật khi có chỉ đạo.</a:t>
             </a:r>
             <a:endParaRPr lang="en-US" dirty="0"/>
           </a:p>
@@ -2263,8 +2361,362 @@
   <p:cSld name="TITLE">
     <p:bg>
       <p:bgPr>
+        <a:blipFill dpi="0" rotWithShape="1">
+          <a:blip r:embed="rId2">
+            <a:lum/>
+          </a:blip>
+          <a:srcRect/>
+          <a:stretch>
+            <a:fillRect/>
+          </a:stretch>
+        </a:blipFill>
+        <a:effectLst/>
+      </p:bgPr>
+    </p:bg>
+    <p:spTree>
+      <p:nvGrpSpPr>
+        <p:cNvPr id="1" name=""/>
+        <p:cNvGrpSpPr/>
+        <p:nvPr/>
+      </p:nvGrpSpPr>
+      <p:grpSpPr>
+        <a:xfrm>
+          <a:off x="0" y="0"/>
+          <a:ext cx="0" cy="0"/>
+          <a:chOff x="0" y="0"/>
+          <a:chExt cx="0" cy="0"/>
+        </a:xfrm>
+      </p:grpSpPr>
+      <p:pic>
+        <p:nvPicPr>
+          <p:cNvPr id="2" name="Image 0" descr="Huy hiệu mẫu (thay bằng logo của trường)">    </p:cNvPr>
+          <p:cNvPicPr>
+            <a:picLocks noChangeAspect="1"/>
+          </p:cNvPicPr>
+          <p:nvPr/>
+        </p:nvPicPr>
+        <p:blipFill>
+          <a:blip r:embed="rId1"/>
+          <a:stretch>
+            <a:fillRect/>
+          </a:stretch>
+        </p:blipFill>
+        <p:spPr>
+          <a:xfrm>
+            <a:off x="548640" y="411480"/>
+            <a:ext cx="502920" cy="502920"/>
+          </a:xfrm>
+          <a:prstGeom prst="rect">
+            <a:avLst/>
+          </a:prstGeom>
+        </p:spPr>
+      </p:pic>
+      <p:sp>
+        <p:nvSpPr>
+          <p:cNvPr id="3" name="Text 0"/>
+          <p:cNvSpPr/>
+          <p:nvPr/>
+        </p:nvSpPr>
+        <p:spPr>
+          <a:xfrm>
+            <a:off x="1188720" y="411480"/>
+            <a:ext cx="5486400" cy="502920"/>
+          </a:xfrm>
+          <a:prstGeom prst="rect">
+            <a:avLst/>
+          </a:prstGeom>
+          <a:noFill/>
+          <a:ln/>
+        </p:spPr>
+        <p:txBody>
+          <a:bodyPr wrap="square" lIns="0" tIns="0" rIns="0" bIns="0" rtlCol="0" anchor="ctr"/>
+          <a:lstStyle/>
+          <a:p>
+            <a:pPr indent="0" marL="0">
+              <a:buNone/>
+            </a:pPr>
+            <a:r>
+              <a:rPr lang="en-US" sz="1400" b="1" dirty="0">
+                <a:solidFill>
+                  <a:srgbClr val="FFFFFF"/>
+                </a:solidFill>
+              </a:rPr>
+              <a:t>Trường Đại học Mẫu A (tên mẫu)</a:t>
+            </a:r>
+            <a:endParaRPr lang="en-US" sz="1400" dirty="0"/>
+          </a:p>
+        </p:txBody>
+      </p:sp>
+      <p:sp>
+        <p:nvSpPr>
+          <p:cNvPr id="4" name="Text 1"/>
+          <p:cNvSpPr/>
+          <p:nvPr>
+            <p:ph idx="102" type="title" hasCustomPrompt="1"/>
+          </p:nvPr>
+        </p:nvSpPr>
+        <p:spPr>
+          <a:xfrm>
+            <a:off x="548640" y="1417320"/>
+            <a:ext cx="6035040" cy="1554480"/>
+          </a:xfrm>
+          <a:prstGeom prst="rect">
+            <a:avLst/>
+          </a:prstGeom>
+          <a:noFill/>
+          <a:ln/>
+        </p:spPr>
+        <p:txBody>
+          <a:bodyPr wrap="square" rtlCol="0"/>
+          <a:lstStyle>
+            <a:lvl1pPr algn="l" indent="0" marL="0">
+              <a:buNone/>
+              <a:defRPr lang="en-US" sz="3600" b="1" dirty="0">
+                <a:solidFill>
+                  <a:srgbClr val="FFFFFF"/>
+                </a:solidFill>
+              </a:defRPr>
+            </a:lvl1pPr>
+          </a:lstStyle>
+          <a:p>
+            <a:pPr algn="l" indent="0" marL="0">
+              <a:buNone/>
+            </a:pPr>
+            <a:endParaRPr lang="en-US" sz="3600" dirty="0"/>
+          </a:p>
+        </p:txBody>
+      </p:sp>
+      <p:sp>
+        <p:nvSpPr>
+          <p:cNvPr id="5" name="Text 1"/>
+          <p:cNvSpPr/>
+          <p:nvPr>
+            <p:ph idx="103" type="body" hasCustomPrompt="1"/>
+          </p:nvPr>
+        </p:nvSpPr>
+        <p:spPr>
+          <a:xfrm>
+            <a:off x="548640" y="3154680"/>
+            <a:ext cx="6035040" cy="1097280"/>
+          </a:xfrm>
+          <a:prstGeom prst="rect">
+            <a:avLst/>
+          </a:prstGeom>
+          <a:noFill/>
+          <a:ln/>
+        </p:spPr>
+        <p:txBody>
+          <a:bodyPr wrap="square" rtlCol="0"/>
+          <a:lstStyle>
+            <a:lvl1pPr algn="l" indent="0" marL="0">
+              <a:buNone/>
+              <a:defRPr lang="en-US" sz="1800" dirty="0">
+                <a:solidFill>
+                  <a:srgbClr val="D6E2F0"/>
+                </a:solidFill>
+              </a:defRPr>
+            </a:lvl1pPr>
+          </a:lstStyle>
+          <a:p>
+            <a:pPr algn="l" indent="0" marL="0">
+              <a:buNone/>
+            </a:pPr>
+            <a:endParaRPr lang="en-US" sz="1800" dirty="0"/>
+          </a:p>
+        </p:txBody>
+      </p:sp>
+    </p:spTree>
+  </p:cSld>
+  <p:clrMapOvr>
+    <a:masterClrMapping/>
+  </p:clrMapOvr>
+</p:sldLayout>
+</file>
+
+<file path=ppt/slideLayouts/slideLayout3.xml><?xml version="1.0" encoding="utf-8"?>
+<p:sldLayout xmlns:a="http://schemas.openxmlformats.org/drawingml/2006/main" xmlns:r="http://schemas.openxmlformats.org/officeDocument/2006/relationships" xmlns:p="http://schemas.openxmlformats.org/presentationml/2006/main" preserve="1">
+  <p:cSld name="CLOSING">
+    <p:bg>
+      <p:bgPr>
+        <a:blipFill dpi="0" rotWithShape="1">
+          <a:blip r:embed="rId2">
+            <a:lum/>
+          </a:blip>
+          <a:srcRect/>
+          <a:stretch>
+            <a:fillRect/>
+          </a:stretch>
+        </a:blipFill>
+        <a:effectLst/>
+      </p:bgPr>
+    </p:bg>
+    <p:spTree>
+      <p:nvGrpSpPr>
+        <p:cNvPr id="1" name=""/>
+        <p:cNvGrpSpPr/>
+        <p:nvPr/>
+      </p:nvGrpSpPr>
+      <p:grpSpPr>
+        <a:xfrm>
+          <a:off x="0" y="0"/>
+          <a:ext cx="0" cy="0"/>
+          <a:chOff x="0" y="0"/>
+          <a:chExt cx="0" cy="0"/>
+        </a:xfrm>
+      </p:grpSpPr>
+      <p:pic>
+        <p:nvPicPr>
+          <p:cNvPr id="2" name="Image 0" descr="Huy hiệu mẫu (thay bằng logo của trường)">    </p:cNvPr>
+          <p:cNvPicPr>
+            <a:picLocks noChangeAspect="1"/>
+          </p:cNvPicPr>
+          <p:nvPr/>
+        </p:nvPicPr>
+        <p:blipFill>
+          <a:blip r:embed="rId1"/>
+          <a:stretch>
+            <a:fillRect/>
+          </a:stretch>
+        </p:blipFill>
+        <p:spPr>
+          <a:xfrm>
+            <a:off x="548640" y="411480"/>
+            <a:ext cx="502920" cy="502920"/>
+          </a:xfrm>
+          <a:prstGeom prst="rect">
+            <a:avLst/>
+          </a:prstGeom>
+        </p:spPr>
+      </p:pic>
+      <p:sp>
+        <p:nvSpPr>
+          <p:cNvPr id="3" name="Text 0"/>
+          <p:cNvSpPr/>
+          <p:nvPr/>
+        </p:nvSpPr>
+        <p:spPr>
+          <a:xfrm>
+            <a:off x="1188720" y="411480"/>
+            <a:ext cx="5486400" cy="502920"/>
+          </a:xfrm>
+          <a:prstGeom prst="rect">
+            <a:avLst/>
+          </a:prstGeom>
+          <a:noFill/>
+          <a:ln/>
+        </p:spPr>
+        <p:txBody>
+          <a:bodyPr wrap="square" lIns="0" tIns="0" rIns="0" bIns="0" rtlCol="0" anchor="ctr"/>
+          <a:lstStyle/>
+          <a:p>
+            <a:pPr indent="0" marL="0">
+              <a:buNone/>
+            </a:pPr>
+            <a:r>
+              <a:rPr lang="en-US" sz="1400" b="1" dirty="0">
+                <a:solidFill>
+                  <a:srgbClr val="FFFFFF"/>
+                </a:solidFill>
+              </a:rPr>
+              <a:t>Trường Đại học Mẫu A (tên mẫu)</a:t>
+            </a:r>
+            <a:endParaRPr lang="en-US" sz="1400" dirty="0"/>
+          </a:p>
+        </p:txBody>
+      </p:sp>
+      <p:sp>
+        <p:nvSpPr>
+          <p:cNvPr id="4" name="Text 1"/>
+          <p:cNvSpPr/>
+          <p:nvPr>
+            <p:ph idx="102" type="title" hasCustomPrompt="1"/>
+          </p:nvPr>
+        </p:nvSpPr>
+        <p:spPr>
+          <a:xfrm>
+            <a:off x="548640" y="1417320"/>
+            <a:ext cx="6035040" cy="1554480"/>
+          </a:xfrm>
+          <a:prstGeom prst="rect">
+            <a:avLst/>
+          </a:prstGeom>
+          <a:noFill/>
+          <a:ln/>
+        </p:spPr>
+        <p:txBody>
+          <a:bodyPr wrap="square" rtlCol="0"/>
+          <a:lstStyle>
+            <a:lvl1pPr algn="l" indent="0" marL="0">
+              <a:buNone/>
+              <a:defRPr lang="en-US" sz="3600" b="1" dirty="0">
+                <a:solidFill>
+                  <a:srgbClr val="FFFFFF"/>
+                </a:solidFill>
+              </a:defRPr>
+            </a:lvl1pPr>
+          </a:lstStyle>
+          <a:p>
+            <a:pPr algn="l" indent="0" marL="0">
+              <a:buNone/>
+            </a:pPr>
+            <a:endParaRPr lang="en-US" sz="3600" dirty="0"/>
+          </a:p>
+        </p:txBody>
+      </p:sp>
+      <p:sp>
+        <p:nvSpPr>
+          <p:cNvPr id="5" name="Text 1"/>
+          <p:cNvSpPr/>
+          <p:nvPr>
+            <p:ph idx="103" type="body" hasCustomPrompt="1"/>
+          </p:nvPr>
+        </p:nvSpPr>
+        <p:spPr>
+          <a:xfrm>
+            <a:off x="548640" y="3154680"/>
+            <a:ext cx="6035040" cy="1097280"/>
+          </a:xfrm>
+          <a:prstGeom prst="rect">
+            <a:avLst/>
+          </a:prstGeom>
+          <a:noFill/>
+          <a:ln/>
+        </p:spPr>
+        <p:txBody>
+          <a:bodyPr wrap="square" rtlCol="0"/>
+          <a:lstStyle>
+            <a:lvl1pPr algn="l" indent="0" marL="0">
+              <a:buNone/>
+              <a:defRPr lang="en-US" sz="1800" dirty="0">
+                <a:solidFill>
+                  <a:srgbClr val="D6E2F0"/>
+                </a:solidFill>
+              </a:defRPr>
+            </a:lvl1pPr>
+          </a:lstStyle>
+          <a:p>
+            <a:pPr algn="l" indent="0" marL="0">
+              <a:buNone/>
+            </a:pPr>
+            <a:endParaRPr lang="en-US" sz="1800" dirty="0"/>
+          </a:p>
+        </p:txBody>
+      </p:sp>
+    </p:spTree>
+  </p:cSld>
+  <p:clrMapOvr>
+    <a:masterClrMapping/>
+  </p:clrMapOvr>
+</p:sldLayout>
+</file>
+
+<file path=ppt/slideLayouts/slideLayout4.xml><?xml version="1.0" encoding="utf-8"?>
+<p:sldLayout xmlns:a="http://schemas.openxmlformats.org/drawingml/2006/main" xmlns:r="http://schemas.openxmlformats.org/officeDocument/2006/relationships" xmlns:p="http://schemas.openxmlformats.org/presentationml/2006/main" preserve="1">
+  <p:cSld name="SECTION">
+    <p:bg>
+      <p:bgPr>
         <a:solidFill>
-          <a:srgbClr val="0F3D3E"/>
+          <a:srgbClr val="0B2A4A"/>
         </a:solidFill>
       </p:bgPr>
     </p:bg>
@@ -2287,13 +2739,13 @@
           <p:cNvPr id="2" name="Text 0"/>
           <p:cNvSpPr/>
           <p:nvPr>
-            <p:ph idx="100" type="title" hasCustomPrompt="1"/>
+            <p:ph idx="100" type="body" hasCustomPrompt="1"/>
           </p:nvPr>
         </p:nvSpPr>
         <p:spPr>
           <a:xfrm>
-            <a:off x="548640" y="1371600"/>
-            <a:ext cx="8046720" cy="1371600"/>
+            <a:off x="548640" y="1097280"/>
+            <a:ext cx="2286000" cy="1463040"/>
           </a:xfrm>
           <a:prstGeom prst="rect">
             <a:avLst/>
@@ -2306,10 +2758,13 @@
           <a:lstStyle>
             <a:lvl1pPr algn="l" indent="0" marL="0">
               <a:buNone/>
-              <a:defRPr lang="en-US" sz="3600" b="1" dirty="0">
-                <a:solidFill>
-                  <a:srgbClr val="FFFFFF"/>
-                </a:solidFill>
+              <a:defRPr lang="en-US" sz="8000" b="1" dirty="0">
+                <a:solidFill>
+                  <a:srgbClr val="B8902B"/>
+                </a:solidFill>
+                <a:latin typeface="Cambria" pitchFamily="34" charset="0"/>
+                <a:ea typeface="Cambria" pitchFamily="34" charset="-122"/>
+                <a:cs typeface="Cambria" pitchFamily="34" charset="-120"/>
               </a:defRPr>
             </a:lvl1pPr>
           </a:lstStyle>
@@ -2317,7 +2772,7 @@
             <a:pPr algn="l" indent="0" marL="0">
               <a:buNone/>
             </a:pPr>
-            <a:endParaRPr lang="en-US" sz="3600" dirty="0"/>
+            <a:endParaRPr lang="en-US" sz="8000" dirty="0"/>
           </a:p>
         </p:txBody>
       </p:sp>
@@ -2326,13 +2781,13 @@
           <p:cNvPr id="3" name="Text 0"/>
           <p:cNvSpPr/>
           <p:nvPr>
-            <p:ph idx="101" type="body" hasCustomPrompt="1"/>
+            <p:ph idx="101" type="title" hasCustomPrompt="1"/>
           </p:nvPr>
         </p:nvSpPr>
         <p:spPr>
           <a:xfrm>
-            <a:off x="548640" y="2926080"/>
-            <a:ext cx="8046720" cy="914400"/>
+            <a:off x="2926080" y="1097280"/>
+            <a:ext cx="5669280" cy="1463040"/>
           </a:xfrm>
           <a:prstGeom prst="rect">
             <a:avLst/>
@@ -2345,9 +2800,9 @@
           <a:lstStyle>
             <a:lvl1pPr algn="l" indent="0" marL="0">
               <a:buNone/>
-              <a:defRPr lang="en-US" sz="1800" dirty="0">
-                <a:solidFill>
-                  <a:srgbClr val="CFE3E1"/>
+              <a:defRPr lang="en-US" sz="3400" b="1" dirty="0">
+                <a:solidFill>
+                  <a:srgbClr val="FFFFFF"/>
                 </a:solidFill>
               </a:defRPr>
             </a:lvl1pPr>
@@ -2356,7 +2811,7 @@
             <a:pPr algn="l" indent="0" marL="0">
               <a:buNone/>
             </a:pPr>
-            <a:endParaRPr lang="en-US" sz="1800" dirty="0"/>
+            <a:endParaRPr lang="en-US" sz="3400" dirty="0"/>
           </a:p>
         </p:txBody>
       </p:sp>
@@ -2368,7 +2823,7 @@
 </p:sldLayout>
 </file>
 
-<file path=ppt/slideLayouts/slideLayout3.xml><?xml version="1.0" encoding="utf-8"?>
+<file path=ppt/slideLayouts/slideLayout5.xml><?xml version="1.0" encoding="utf-8"?>
 <p:sldLayout xmlns:a="http://schemas.openxmlformats.org/drawingml/2006/main" xmlns:r="http://schemas.openxmlformats.org/officeDocument/2006/relationships" xmlns:p="http://schemas.openxmlformats.org/presentationml/2006/main" preserve="1">
   <p:cSld name="CONTENT">
     <p:bg>
@@ -2402,8 +2857,8 @@
         </p:nvSpPr>
         <p:spPr>
           <a:xfrm>
-            <a:off x="457200" y="274320"/>
-            <a:ext cx="8229600" cy="868680"/>
+            <a:off x="548640" y="274320"/>
+            <a:ext cx="8046720" cy="868680"/>
           </a:xfrm>
           <a:prstGeom prst="rect">
             <a:avLst/>
@@ -2418,7 +2873,7 @@
               <a:buNone/>
               <a:defRPr lang="en-US" sz="2800" b="1" dirty="0">
                 <a:solidFill>
-                  <a:srgbClr val="0F3D3E"/>
+                  <a:srgbClr val="0B2A4A"/>
                 </a:solidFill>
               </a:defRPr>
             </a:lvl1pPr>
@@ -2428,6 +2883,87 @@
               <a:buNone/>
             </a:pPr>
             <a:endParaRPr lang="en-US" sz="2800" dirty="0"/>
+          </a:p>
+        </p:txBody>
+      </p:sp>
+      <p:sp>
+        <p:nvSpPr>
+          <p:cNvPr id="3" name="Text 0"/>
+          <p:cNvSpPr/>
+          <p:nvPr/>
+        </p:nvSpPr>
+        <p:spPr>
+          <a:xfrm>
+            <a:off x="548640" y="4727448"/>
+            <a:ext cx="5943600" cy="274320"/>
+          </a:xfrm>
+          <a:prstGeom prst="rect">
+            <a:avLst/>
+          </a:prstGeom>
+          <a:noFill/>
+          <a:ln/>
+        </p:spPr>
+        <p:txBody>
+          <a:bodyPr wrap="square" lIns="0" tIns="0" rIns="0" bIns="0" rtlCol="0" anchor="ctr"/>
+          <a:lstStyle/>
+          <a:p>
+            <a:pPr indent="0" marL="0">
+              <a:buNone/>
+            </a:pPr>
+            <a:r>
+              <a:rPr lang="en-US" sz="1100" dirty="0">
+                <a:solidFill>
+                  <a:srgbClr val="6B7A90"/>
+                </a:solidFill>
+              </a:rPr>
+              <a:t>Hội nghị tổng kết năm học 2025–2026</a:t>
+            </a:r>
+            <a:endParaRPr lang="en-US" sz="1100" dirty="0"/>
+          </a:p>
+        </p:txBody>
+      </p:sp>
+      <p:sp>
+        <p:nvSpPr>
+          <p:cNvPr id="25" name="Slide Number Placeholder 0"/>
+          <p:cNvSpPr>
+            <a:spLocks noGrp="1"/>
+          </p:cNvSpPr>
+          <p:nvPr>
+            <p:ph type="sldNum" sz="quarter" idx="4294967295"/>
+          </p:nvPr>
+        </p:nvSpPr>
+        <p:spPr>
+          <a:xfrm>
+            <a:off x="8138160" y="4727448"/>
+            <a:ext cx="457200" cy="274320"/>
+          </a:xfrm>
+          <a:prstGeom prst="rect">
+            <a:avLst/>
+          </a:prstGeom>
+          <a:extLst>
+            <a:ext uri="{C572A759-6A51-4108-AA02-DFA0A04FC94B}">
+              <ma14:wrappingTextBoxFlag xmlns:ma14="http://schemas.microsoft.com/office/mac/drawingml/2011/main" val="0"/>
+            </a:ext>
+          </a:extLst>
+        </p:spPr>
+        <p:txBody>
+          <a:bodyPr/>
+          <a:lstStyle>
+            <a:lvl1pPr>
+              <a:defRPr sz="1100">
+                <a:solidFill>
+                  <a:srgbClr val="6B7A90"/>
+                </a:solidFill>
+              </a:defRPr>
+            </a:lvl1pPr>
+          </a:lstStyle>
+          <a:p>
+            <a:pPr algn="r"/>
+            <a:fld id="{F7021451-1387-4CA6-816F-3879F97B5CBC}" type="slidenum">
+              <a:rPr b="0" lang="en-US"/>
+              <a:t>1005</a:t>
+            </a:fld>
+            <a:endParaRPr lang="en-US"/>
           </a:p>
         </p:txBody>
       </p:sp>
@@ -2456,6 +2992,51 @@
           <a:chExt cx="0" cy="0"/>
         </a:xfrm>
       </p:grpSpPr>
+      <p:sp>
+        <p:nvSpPr>
+          <p:cNvPr id="25" name="Slide Number Placeholder 0"/>
+          <p:cNvSpPr>
+            <a:spLocks noGrp="1"/>
+          </p:cNvSpPr>
+          <p:nvPr>
+            <p:ph type="sldNum" sz="quarter" idx="4294967295"/>
+          </p:nvPr>
+        </p:nvSpPr>
+        <p:spPr>
+          <a:xfrm>
+            <a:off x="8138160" y="4727448"/>
+            <a:ext cx="457200" cy="274320"/>
+          </a:xfrm>
+          <a:prstGeom prst="rect">
+            <a:avLst/>
+          </a:prstGeom>
+          <a:extLst>
+            <a:ext uri="{C572A759-6A51-4108-AA02-DFA0A04FC94B}">
+              <ma14:wrappingTextBoxFlag xmlns:ma14="http://schemas.microsoft.com/office/mac/drawingml/2011/main" val="0"/>
+            </a:ext>
+          </a:extLst>
+        </p:spPr>
+        <p:txBody>
+          <a:bodyPr/>
+          <a:lstStyle>
+            <a:lvl1pPr>
+              <a:defRPr sz="1100">
+                <a:solidFill>
+                  <a:srgbClr val="6B7A90"/>
+                </a:solidFill>
+              </a:defRPr>
+            </a:lvl1pPr>
+          </a:lstStyle>
+          <a:p>
+            <a:pPr algn="r"/>
+            <a:fld id="{F7021451-1387-4CA6-816F-3879F97B5CBC}" type="slidenum">
+              <a:rPr b="0" lang="en-US"/>
+              <a:t>null</a:t>
+            </a:fld>
+            <a:endParaRPr lang="en-US"/>
+          </a:p>
+        </p:txBody>
+      </p:sp>
     </p:spTree>
   </p:cSld>
   <p:clrMap bg1="lt1" tx1="dk1" bg2="lt2" tx2="dk2" accent1="accent1" accent2="accent2" accent3="accent3" accent4="accent4" accent5="accent5" accent6="accent6" hlink="hlink" folHlink="folHlink"/>
@@ -2463,6 +3044,8 @@
     <p:sldLayoutId id="2147483649" r:id="rId1"/>
     <p:sldLayoutId id="2147483650" r:id="rId2"/>
     <p:sldLayoutId id="2147483651" r:id="rId3"/>
+    <p:sldLayoutId id="2147483652" r:id="rId4"/>
+    <p:sldLayoutId id="2147483653" r:id="rId5"/>
   </p:sldLayoutIdLst>
   <p:hf sldNum="0" hdr="0" ftr="0" dt="0"/>
   <p:txStyles>
@@ -2737,16 +3320,16 @@
       </p:grpSpPr>
       <p:sp>
         <p:nvSpPr>
-          <p:cNvPr id="2" name="Text 0"/>
+          <p:cNvPr id="2" name="Text 1"/>
           <p:cNvSpPr/>
           <p:nvPr>
-            <p:ph idx="100" type="title" hasCustomPrompt="1"/>
+            <p:ph idx="102" type="title" hasCustomPrompt="1"/>
           </p:nvPr>
         </p:nvSpPr>
         <p:spPr>
           <a:xfrm>
-            <a:off x="548640" y="1371600"/>
-            <a:ext cx="8046720" cy="1371600"/>
+            <a:off x="548640" y="1417320"/>
+            <a:ext cx="6035040" cy="1554480"/>
           </a:xfrm>
           <a:prstGeom prst="rect">
             <a:avLst/>
@@ -2775,16 +3358,16 @@
       </p:sp>
       <p:sp>
         <p:nvSpPr>
-          <p:cNvPr id="3" name="Text 0"/>
+          <p:cNvPr id="3" name="Text 1"/>
           <p:cNvSpPr/>
           <p:nvPr>
-            <p:ph idx="101" type="body" hasCustomPrompt="1"/>
+            <p:ph idx="103" type="body" hasCustomPrompt="1"/>
           </p:nvPr>
         </p:nvSpPr>
         <p:spPr>
           <a:xfrm>
-            <a:off x="548640" y="2926080"/>
-            <a:ext cx="8046720" cy="914400"/>
+            <a:off x="548640" y="3154680"/>
+            <a:ext cx="6035040" cy="1097280"/>
           </a:xfrm>
           <a:prstGeom prst="rect">
             <a:avLst/>
@@ -2802,10 +3385,111 @@
             <a:r>
               <a:rPr lang="en-US" sz="1800" dirty="0">
                 <a:solidFill>
-                  <a:srgbClr val="CFE3E1"/>
+                  <a:srgbClr val="D6E2F0"/>
                 </a:solidFill>
               </a:rPr>
-              <a:t>Hội nghị tổng kết · Trường Đại học Mẫu A (tên mẫu)</a:t>
+              <a:t>Hội nghị tổng kết toàn trường</a:t>
+            </a:r>
+            <a:endParaRPr lang="en-US" sz="1800" dirty="0"/>
+          </a:p>
+        </p:txBody>
+      </p:sp>
+    </p:spTree>
+  </p:cSld>
+  <p:clrMapOvr>
+    <a:masterClrMapping/>
+  </p:clrMapOvr>
+</p:sld>
+</file>
+
+<file path=ppt/slides/slide10.xml><?xml version="1.0" encoding="utf-8"?>
+<p:sld xmlns:a="http://schemas.openxmlformats.org/drawingml/2006/main" xmlns:r="http://schemas.openxmlformats.org/officeDocument/2006/relationships" xmlns:p="http://schemas.openxmlformats.org/presentationml/2006/main">
+  <p:cSld name="Slide 10">
+    <p:spTree>
+      <p:nvGrpSpPr>
+        <p:cNvPr id="1" name=""/>
+        <p:cNvGrpSpPr/>
+        <p:nvPr/>
+      </p:nvGrpSpPr>
+      <p:grpSpPr>
+        <a:xfrm>
+          <a:off x="0" y="0"/>
+          <a:ext cx="0" cy="0"/>
+          <a:chOff x="0" y="0"/>
+          <a:chExt cx="0" cy="0"/>
+        </a:xfrm>
+      </p:grpSpPr>
+      <p:sp>
+        <p:nvSpPr>
+          <p:cNvPr id="2" name="Text 1"/>
+          <p:cNvSpPr/>
+          <p:nvPr>
+            <p:ph idx="102" type="title" hasCustomPrompt="1"/>
+          </p:nvPr>
+        </p:nvSpPr>
+        <p:spPr>
+          <a:xfrm>
+            <a:off x="548640" y="1417320"/>
+            <a:ext cx="6035040" cy="1554480"/>
+          </a:xfrm>
+          <a:prstGeom prst="rect">
+            <a:avLst/>
+          </a:prstGeom>
+          <a:noFill/>
+          <a:ln/>
+        </p:spPr>
+        <p:txBody>
+          <a:bodyPr wrap="square" lIns="0" tIns="0" rIns="0" bIns="0" rtlCol="0" anchor="b"/>
+          <a:lstStyle/>
+          <a:p>
+            <a:pPr algn="l" indent="0" marL="0">
+              <a:buNone/>
+            </a:pPr>
+            <a:r>
+              <a:rPr lang="en-US" sz="3600" b="1" dirty="0">
+                <a:solidFill>
+                  <a:srgbClr val="FFFFFF"/>
+                </a:solidFill>
+              </a:rPr>
+              <a:t>Trân trọng cảm ơn</a:t>
+            </a:r>
+            <a:endParaRPr lang="en-US" sz="3600" dirty="0"/>
+          </a:p>
+        </p:txBody>
+      </p:sp>
+      <p:sp>
+        <p:nvSpPr>
+          <p:cNvPr id="3" name="Text 1"/>
+          <p:cNvSpPr/>
+          <p:nvPr>
+            <p:ph idx="103" type="body" hasCustomPrompt="1"/>
+          </p:nvPr>
+        </p:nvSpPr>
+        <p:spPr>
+          <a:xfrm>
+            <a:off x="548640" y="3154680"/>
+            <a:ext cx="6035040" cy="1097280"/>
+          </a:xfrm>
+          <a:prstGeom prst="rect">
+            <a:avLst/>
+          </a:prstGeom>
+          <a:noFill/>
+          <a:ln/>
+        </p:spPr>
+        <p:txBody>
+          <a:bodyPr wrap="square" lIns="0" tIns="0" rIns="0" bIns="0" rtlCol="0" anchor="t"/>
+          <a:lstStyle/>
+          <a:p>
+            <a:pPr algn="l" indent="0" marL="0">
+              <a:buNone/>
+            </a:pPr>
+            <a:r>
+              <a:rPr lang="en-US" sz="1800" dirty="0">
+                <a:solidFill>
+                  <a:srgbClr val="D6E2F0"/>
+                </a:solidFill>
+              </a:rPr>
+              <a:t>Trao đổi và góp ý</a:t>
             </a:r>
             <a:endParaRPr lang="en-US" sz="1800" dirty="0"/>
           </a:p>
@@ -2846,8 +3530,8 @@
         </p:nvSpPr>
         <p:spPr>
           <a:xfrm>
-            <a:off x="457200" y="274320"/>
-            <a:ext cx="8229600" cy="868680"/>
+            <a:off x="548640" y="274320"/>
+            <a:ext cx="8046720" cy="868680"/>
           </a:xfrm>
           <a:prstGeom prst="rect">
             <a:avLst/>
@@ -2865,10 +3549,10 @@
             <a:r>
               <a:rPr lang="en-US" sz="2800" b="1" dirty="0">
                 <a:solidFill>
-                  <a:srgbClr val="0F3D3E"/>
+                  <a:srgbClr val="0B2A4A"/>
                 </a:solidFill>
               </a:rPr>
-              <a:t>Năm học 2025–2026 nhập học đạt 91,2% chỉ tiêu</a:t>
+              <a:t>Nội dung chính của hội nghị</a:t>
             </a:r>
             <a:endParaRPr lang="en-US" sz="2800" dirty="0"/>
           </a:p>
@@ -2882,20 +3566,20 @@
         </p:nvSpPr>
         <p:spPr>
           <a:xfrm>
-            <a:off x="457200" y="1371600"/>
-            <a:ext cx="2606040" cy="1737360"/>
+            <a:off x="548640" y="1325880"/>
+            <a:ext cx="8046720" cy="658368"/>
           </a:xfrm>
           <a:prstGeom prst="roundRect">
             <a:avLst>
-              <a:gd name="adj" fmla="val 5263"/>
+              <a:gd name="adj" fmla="val 11111"/>
             </a:avLst>
           </a:prstGeom>
           <a:solidFill>
-            <a:srgbClr val="EEF3F2"/>
+            <a:srgbClr val="F1F4F8"/>
           </a:solidFill>
           <a:ln w="12700">
             <a:solidFill>
-              <a:srgbClr val="EEF3F2"/>
+              <a:srgbClr val="F1F4F8"/>
             </a:solidFill>
             <a:prstDash val="solid"/>
           </a:ln>
@@ -2903,14 +3587,39 @@
       </p:sp>
       <p:sp>
         <p:nvSpPr>
-          <p:cNvPr id="5" name="so-lieu"/>
+          <p:cNvPr id="5" name="so-thu-tu"/>
+          <p:cNvSpPr/>
+          <p:nvPr/>
+        </p:nvSpPr>
+        <p:spPr>
+          <a:xfrm>
+            <a:off x="777240" y="1357884"/>
+            <a:ext cx="594360" cy="594360"/>
+          </a:xfrm>
+          <a:prstGeom prst="ellipse">
+            <a:avLst/>
+          </a:prstGeom>
+          <a:solidFill>
+            <a:srgbClr val="1F4E8C"/>
+          </a:solidFill>
+          <a:ln w="12700">
+            <a:solidFill>
+              <a:srgbClr val="1F4E8C"/>
+            </a:solidFill>
+            <a:prstDash val="solid"/>
+          </a:ln>
+        </p:spPr>
+      </p:sp>
+      <p:sp>
+        <p:nvSpPr>
+          <p:cNvPr id="6" name="so-thu-tu-chu"/>
           <p:cNvSpPr txBox="1"/>
           <p:nvPr/>
         </p:nvSpPr>
         <p:spPr>
           <a:xfrm>
-            <a:off x="594360" y="1508760"/>
-            <a:ext cx="2331720" cy="822960"/>
+            <a:off x="777240" y="1357884"/>
+            <a:ext cx="594360" cy="594360"/>
           </a:xfrm>
           <a:prstGeom prst="rect">
             <a:avLst/>
@@ -2922,34 +3631,34 @@
           <a:bodyPr wrap="square" lIns="0" tIns="0" rIns="0" bIns="0" rtlCol="0" anchor="ctr"/>
           <a:lstStyle/>
           <a:p>
-            <a:pPr indent="0" marL="0">
+            <a:pPr algn="ctr" indent="0" marL="0">
               <a:buNone/>
             </a:pPr>
             <a:r>
-              <a:rPr lang="en-US" sz="4000" b="1" dirty="0">
-                <a:solidFill>
-                  <a:srgbClr val="0F6E6E"/>
+              <a:rPr lang="en-US" sz="2200" b="1" dirty="0">
+                <a:solidFill>
+                  <a:srgbClr val="FFFFFF"/>
                 </a:solidFill>
                 <a:latin typeface="Cambria" pitchFamily="34" charset="0"/>
                 <a:ea typeface="Cambria" pitchFamily="34" charset="-122"/>
                 <a:cs typeface="Cambria" pitchFamily="34" charset="-120"/>
               </a:rPr>
-              <a:t>91,2%</a:t>
-            </a:r>
-            <a:endParaRPr lang="en-US" sz="4000" dirty="0"/>
-          </a:p>
-        </p:txBody>
-      </p:sp>
-      <p:sp>
-        <p:nvSpPr>
-          <p:cNvPr id="6" name="nhan"/>
+              <a:t>1</a:t>
+            </a:r>
+            <a:endParaRPr lang="en-US" sz="2200" dirty="0"/>
+          </a:p>
+        </p:txBody>
+      </p:sp>
+      <p:sp>
+        <p:nvSpPr>
+          <p:cNvPr id="7" name="the-chu"/>
           <p:cNvSpPr txBox="1"/>
           <p:nvPr/>
         </p:nvSpPr>
         <p:spPr>
           <a:xfrm>
-            <a:off x="594360" y="2331720"/>
-            <a:ext cx="2331720" cy="685800"/>
+            <a:off x="1600200" y="1399032"/>
+            <a:ext cx="6766560" cy="512064"/>
           </a:xfrm>
           <a:prstGeom prst="rect">
             <a:avLst/>
@@ -2958,46 +3667,46 @@
           <a:ln/>
         </p:spPr>
         <p:txBody>
-          <a:bodyPr wrap="square" lIns="0" tIns="0" rIns="0" bIns="0" rtlCol="0" anchor="t"/>
+          <a:bodyPr wrap="square" lIns="0" tIns="0" rIns="0" bIns="0" rtlCol="0" anchor="ctr"/>
           <a:lstStyle/>
           <a:p>
             <a:pPr indent="0" marL="0">
               <a:buNone/>
             </a:pPr>
             <a:r>
-              <a:rPr lang="en-US" sz="1400" dirty="0">
-                <a:solidFill>
-                  <a:srgbClr val="1B1F2A"/>
+              <a:rPr lang="en-US" sz="1800" b="1" dirty="0">
+                <a:solidFill>
+                  <a:srgbClr val="0B2A4A"/>
                 </a:solidFill>
               </a:rPr>
-              <a:t>nhập học 1.642 trên chỉ tiêu 1.800</a:t>
-            </a:r>
-            <a:endParaRPr lang="en-US" sz="1400" dirty="0"/>
-          </a:p>
-        </p:txBody>
-      </p:sp>
-      <p:sp>
-        <p:nvSpPr>
-          <p:cNvPr id="7" name="the"/>
+              <a:t>Kết quả chính của năm học</a:t>
+            </a:r>
+            <a:endParaRPr lang="en-US" sz="1800" dirty="0"/>
+          </a:p>
+        </p:txBody>
+      </p:sp>
+      <p:sp>
+        <p:nvSpPr>
+          <p:cNvPr id="8" name="the"/>
           <p:cNvSpPr/>
           <p:nvPr/>
         </p:nvSpPr>
         <p:spPr>
           <a:xfrm>
-            <a:off x="3268980" y="1371600"/>
-            <a:ext cx="2606040" cy="1737360"/>
+            <a:off x="548640" y="2103120"/>
+            <a:ext cx="8046720" cy="658368"/>
           </a:xfrm>
           <a:prstGeom prst="roundRect">
             <a:avLst>
-              <a:gd name="adj" fmla="val 5263"/>
+              <a:gd name="adj" fmla="val 11111"/>
             </a:avLst>
           </a:prstGeom>
           <a:solidFill>
-            <a:srgbClr val="EEF3F2"/>
+            <a:srgbClr val="F1F4F8"/>
           </a:solidFill>
           <a:ln w="12700">
             <a:solidFill>
-              <a:srgbClr val="EEF3F2"/>
+              <a:srgbClr val="F1F4F8"/>
             </a:solidFill>
             <a:prstDash val="solid"/>
           </a:ln>
@@ -3005,14 +3714,39 @@
       </p:sp>
       <p:sp>
         <p:nvSpPr>
-          <p:cNvPr id="8" name="so-lieu"/>
+          <p:cNvPr id="9" name="so-thu-tu"/>
+          <p:cNvSpPr/>
+          <p:nvPr/>
+        </p:nvSpPr>
+        <p:spPr>
+          <a:xfrm>
+            <a:off x="777240" y="2135124"/>
+            <a:ext cx="594360" cy="594360"/>
+          </a:xfrm>
+          <a:prstGeom prst="ellipse">
+            <a:avLst/>
+          </a:prstGeom>
+          <a:solidFill>
+            <a:srgbClr val="1F4E8C"/>
+          </a:solidFill>
+          <a:ln w="12700">
+            <a:solidFill>
+              <a:srgbClr val="1F4E8C"/>
+            </a:solidFill>
+            <a:prstDash val="solid"/>
+          </a:ln>
+        </p:spPr>
+      </p:sp>
+      <p:sp>
+        <p:nvSpPr>
+          <p:cNvPr id="10" name="so-thu-tu-chu"/>
           <p:cNvSpPr txBox="1"/>
           <p:nvPr/>
         </p:nvSpPr>
         <p:spPr>
           <a:xfrm>
-            <a:off x="3406140" y="1508760"/>
-            <a:ext cx="2331720" cy="822960"/>
+            <a:off x="777240" y="2135124"/>
+            <a:ext cx="594360" cy="594360"/>
           </a:xfrm>
           <a:prstGeom prst="rect">
             <a:avLst/>
@@ -3024,34 +3758,34 @@
           <a:bodyPr wrap="square" lIns="0" tIns="0" rIns="0" bIns="0" rtlCol="0" anchor="ctr"/>
           <a:lstStyle/>
           <a:p>
-            <a:pPr indent="0" marL="0">
+            <a:pPr algn="ctr" indent="0" marL="0">
               <a:buNone/>
             </a:pPr>
             <a:r>
-              <a:rPr lang="en-US" sz="4000" b="1" dirty="0">
-                <a:solidFill>
-                  <a:srgbClr val="D9822B"/>
+              <a:rPr lang="en-US" sz="2200" b="1" dirty="0">
+                <a:solidFill>
+                  <a:srgbClr val="FFFFFF"/>
                 </a:solidFill>
                 <a:latin typeface="Cambria" pitchFamily="34" charset="0"/>
                 <a:ea typeface="Cambria" pitchFamily="34" charset="-122"/>
                 <a:cs typeface="Cambria" pitchFamily="34" charset="-120"/>
               </a:rPr>
-              <a:t>84%</a:t>
-            </a:r>
-            <a:endParaRPr lang="en-US" sz="4000" dirty="0"/>
-          </a:p>
-        </p:txBody>
-      </p:sp>
-      <p:sp>
-        <p:nvSpPr>
-          <p:cNvPr id="9" name="nhan"/>
+              <a:t>2</a:t>
+            </a:r>
+            <a:endParaRPr lang="en-US" sz="2200" dirty="0"/>
+          </a:p>
+        </p:txBody>
+      </p:sp>
+      <p:sp>
+        <p:nvSpPr>
+          <p:cNvPr id="11" name="the-chu"/>
           <p:cNvSpPr txBox="1"/>
           <p:nvPr/>
         </p:nvSpPr>
         <p:spPr>
           <a:xfrm>
-            <a:off x="3406140" y="2331720"/>
-            <a:ext cx="2331720" cy="685800"/>
+            <a:off x="1600200" y="2176272"/>
+            <a:ext cx="6766560" cy="512064"/>
           </a:xfrm>
           <a:prstGeom prst="rect">
             <a:avLst/>
@@ -3060,46 +3794,46 @@
           <a:ln/>
         </p:spPr>
         <p:txBody>
-          <a:bodyPr wrap="square" lIns="0" tIns="0" rIns="0" bIns="0" rtlCol="0" anchor="t"/>
+          <a:bodyPr wrap="square" lIns="0" tIns="0" rIns="0" bIns="0" rtlCol="0" anchor="ctr"/>
           <a:lstStyle/>
           <a:p>
             <a:pPr indent="0" marL="0">
               <a:buNone/>
             </a:pPr>
             <a:r>
-              <a:rPr lang="en-US" sz="1400" dirty="0">
-                <a:solidFill>
-                  <a:srgbClr val="1B1F2A"/>
+              <a:rPr lang="en-US" sz="1800" b="1" dirty="0">
+                <a:solidFill>
+                  <a:srgbClr val="0B2A4A"/>
                 </a:solidFill>
               </a:rPr>
-              <a:t>tốt nghiệp đúng hạn, năm học 2024–2025 (năm gần nhất có số liệu)</a:t>
-            </a:r>
-            <a:endParaRPr lang="en-US" sz="1400" dirty="0"/>
-          </a:p>
-        </p:txBody>
-      </p:sp>
-      <p:sp>
-        <p:nvSpPr>
-          <p:cNvPr id="10" name="the"/>
+              <a:t>Đào tạo: tuyển sinh và tốt nghiệp</a:t>
+            </a:r>
+            <a:endParaRPr lang="en-US" sz="1800" dirty="0"/>
+          </a:p>
+        </p:txBody>
+      </p:sp>
+      <p:sp>
+        <p:nvSpPr>
+          <p:cNvPr id="12" name="the"/>
           <p:cNvSpPr/>
           <p:nvPr/>
         </p:nvSpPr>
         <p:spPr>
           <a:xfrm>
-            <a:off x="6080760" y="1371600"/>
-            <a:ext cx="2606040" cy="1737360"/>
+            <a:off x="548640" y="2880360"/>
+            <a:ext cx="8046720" cy="658368"/>
           </a:xfrm>
           <a:prstGeom prst="roundRect">
             <a:avLst>
-              <a:gd name="adj" fmla="val 5263"/>
+              <a:gd name="adj" fmla="val 11111"/>
             </a:avLst>
           </a:prstGeom>
           <a:solidFill>
-            <a:srgbClr val="EEF3F2"/>
+            <a:srgbClr val="F1F4F8"/>
           </a:solidFill>
           <a:ln w="12700">
             <a:solidFill>
-              <a:srgbClr val="EEF3F2"/>
+              <a:srgbClr val="F1F4F8"/>
             </a:solidFill>
             <a:prstDash val="solid"/>
           </a:ln>
@@ -3107,14 +3841,39 @@
       </p:sp>
       <p:sp>
         <p:nvSpPr>
-          <p:cNvPr id="11" name="so-lieu"/>
+          <p:cNvPr id="13" name="so-thu-tu"/>
+          <p:cNvSpPr/>
+          <p:nvPr/>
+        </p:nvSpPr>
+        <p:spPr>
+          <a:xfrm>
+            <a:off x="777240" y="2912364"/>
+            <a:ext cx="594360" cy="594360"/>
+          </a:xfrm>
+          <a:prstGeom prst="ellipse">
+            <a:avLst/>
+          </a:prstGeom>
+          <a:solidFill>
+            <a:srgbClr val="1F4E8C"/>
+          </a:solidFill>
+          <a:ln w="12700">
+            <a:solidFill>
+              <a:srgbClr val="1F4E8C"/>
+            </a:solidFill>
+            <a:prstDash val="solid"/>
+          </a:ln>
+        </p:spPr>
+      </p:sp>
+      <p:sp>
+        <p:nvSpPr>
+          <p:cNvPr id="14" name="so-thu-tu-chu"/>
           <p:cNvSpPr txBox="1"/>
           <p:nvPr/>
         </p:nvSpPr>
         <p:spPr>
           <a:xfrm>
-            <a:off x="6217920" y="1508760"/>
-            <a:ext cx="2331720" cy="822960"/>
+            <a:off x="777240" y="2912364"/>
+            <a:ext cx="594360" cy="594360"/>
           </a:xfrm>
           <a:prstGeom prst="rect">
             <a:avLst/>
@@ -3126,34 +3885,34 @@
           <a:bodyPr wrap="square" lIns="0" tIns="0" rIns="0" bIns="0" rtlCol="0" anchor="ctr"/>
           <a:lstStyle/>
           <a:p>
-            <a:pPr indent="0" marL="0">
+            <a:pPr algn="ctr" indent="0" marL="0">
               <a:buNone/>
             </a:pPr>
             <a:r>
-              <a:rPr lang="en-US" sz="4000" b="1" dirty="0">
-                <a:solidFill>
-                  <a:srgbClr val="0F6E6E"/>
+              <a:rPr lang="en-US" sz="2200" b="1" dirty="0">
+                <a:solidFill>
+                  <a:srgbClr val="FFFFFF"/>
                 </a:solidFill>
                 <a:latin typeface="Cambria" pitchFamily="34" charset="0"/>
                 <a:ea typeface="Cambria" pitchFamily="34" charset="-122"/>
                 <a:cs typeface="Cambria" pitchFamily="34" charset="-120"/>
               </a:rPr>
-              <a:t>412.000</a:t>
-            </a:r>
-            <a:endParaRPr lang="en-US" sz="4000" dirty="0"/>
-          </a:p>
-        </p:txBody>
-      </p:sp>
-      <p:sp>
-        <p:nvSpPr>
-          <p:cNvPr id="12" name="nhan"/>
+              <a:t>3</a:t>
+            </a:r>
+            <a:endParaRPr lang="en-US" sz="2200" dirty="0"/>
+          </a:p>
+        </p:txBody>
+      </p:sp>
+      <p:sp>
+        <p:nvSpPr>
+          <p:cNvPr id="15" name="the-chu"/>
           <p:cNvSpPr txBox="1"/>
           <p:nvPr/>
         </p:nvSpPr>
         <p:spPr>
           <a:xfrm>
-            <a:off x="6217920" y="2331720"/>
-            <a:ext cx="2331720" cy="685800"/>
+            <a:off x="1600200" y="2953512"/>
+            <a:ext cx="6766560" cy="512064"/>
           </a:xfrm>
           <a:prstGeom prst="rect">
             <a:avLst/>
@@ -3162,34 +3921,86 @@
           <a:ln/>
         </p:spPr>
         <p:txBody>
-          <a:bodyPr wrap="square" lIns="0" tIns="0" rIns="0" bIns="0" rtlCol="0" anchor="t"/>
+          <a:bodyPr wrap="square" lIns="0" tIns="0" rIns="0" bIns="0" rtlCol="0" anchor="ctr"/>
           <a:lstStyle/>
           <a:p>
             <a:pPr indent="0" marL="0">
               <a:buNone/>
             </a:pPr>
             <a:r>
-              <a:rPr lang="en-US" sz="1400" dirty="0">
-                <a:solidFill>
-                  <a:srgbClr val="1B1F2A"/>
+              <a:rPr lang="en-US" sz="1800" b="1" dirty="0">
+                <a:solidFill>
+                  <a:srgbClr val="0B2A4A"/>
                 </a:solidFill>
               </a:rPr>
-              <a:t>triệu đồng tổng thu năm học</a:t>
-            </a:r>
-            <a:endParaRPr lang="en-US" sz="1400" dirty="0"/>
-          </a:p>
-        </p:txBody>
-      </p:sp>
-      <p:sp>
-        <p:nvSpPr>
-          <p:cNvPr id="13" name="nguon"/>
+              <a:t>Tài chính và công tác sinh viên</a:t>
+            </a:r>
+            <a:endParaRPr lang="en-US" sz="1800" dirty="0"/>
+          </a:p>
+        </p:txBody>
+      </p:sp>
+      <p:sp>
+        <p:nvSpPr>
+          <p:cNvPr id="16" name="the"/>
+          <p:cNvSpPr/>
+          <p:nvPr/>
+        </p:nvSpPr>
+        <p:spPr>
+          <a:xfrm>
+            <a:off x="548640" y="3657600"/>
+            <a:ext cx="8046720" cy="658368"/>
+          </a:xfrm>
+          <a:prstGeom prst="roundRect">
+            <a:avLst>
+              <a:gd name="adj" fmla="val 11111"/>
+            </a:avLst>
+          </a:prstGeom>
+          <a:solidFill>
+            <a:srgbClr val="F1F4F8"/>
+          </a:solidFill>
+          <a:ln w="12700">
+            <a:solidFill>
+              <a:srgbClr val="F1F4F8"/>
+            </a:solidFill>
+            <a:prstDash val="solid"/>
+          </a:ln>
+        </p:spPr>
+      </p:sp>
+      <p:sp>
+        <p:nvSpPr>
+          <p:cNvPr id="17" name="so-thu-tu"/>
+          <p:cNvSpPr/>
+          <p:nvPr/>
+        </p:nvSpPr>
+        <p:spPr>
+          <a:xfrm>
+            <a:off x="777240" y="3689604"/>
+            <a:ext cx="594360" cy="594360"/>
+          </a:xfrm>
+          <a:prstGeom prst="ellipse">
+            <a:avLst/>
+          </a:prstGeom>
+          <a:solidFill>
+            <a:srgbClr val="1F4E8C"/>
+          </a:solidFill>
+          <a:ln w="12700">
+            <a:solidFill>
+              <a:srgbClr val="1F4E8C"/>
+            </a:solidFill>
+            <a:prstDash val="solid"/>
+          </a:ln>
+        </p:spPr>
+      </p:sp>
+      <p:sp>
+        <p:nvSpPr>
+          <p:cNvPr id="18" name="so-thu-tu-chu"/>
           <p:cNvSpPr txBox="1"/>
           <p:nvPr/>
         </p:nvSpPr>
         <p:spPr>
           <a:xfrm>
-            <a:off x="457200" y="4617720"/>
-            <a:ext cx="8229600" cy="320040"/>
+            <a:off x="777240" y="3689604"/>
+            <a:ext cx="594360" cy="594360"/>
           </a:xfrm>
           <a:prstGeom prst="rect">
             <a:avLst/>
@@ -3201,18 +4012,102 @@
           <a:bodyPr wrap="square" lIns="0" tIns="0" rIns="0" bIns="0" rtlCol="0" anchor="ctr"/>
           <a:lstStyle/>
           <a:p>
+            <a:pPr algn="ctr" indent="0" marL="0">
+              <a:buNone/>
+            </a:pPr>
+            <a:r>
+              <a:rPr lang="en-US" sz="2200" b="1" dirty="0">
+                <a:solidFill>
+                  <a:srgbClr val="FFFFFF"/>
+                </a:solidFill>
+                <a:latin typeface="Cambria" pitchFamily="34" charset="0"/>
+                <a:ea typeface="Cambria" pitchFamily="34" charset="-122"/>
+                <a:cs typeface="Cambria" pitchFamily="34" charset="-120"/>
+              </a:rPr>
+              <a:t>4</a:t>
+            </a:r>
+            <a:endParaRPr lang="en-US" sz="2200" dirty="0"/>
+          </a:p>
+        </p:txBody>
+      </p:sp>
+      <p:sp>
+        <p:nvSpPr>
+          <p:cNvPr id="19" name="the-chu"/>
+          <p:cNvSpPr txBox="1"/>
+          <p:nvPr/>
+        </p:nvSpPr>
+        <p:spPr>
+          <a:xfrm>
+            <a:off x="1600200" y="3730752"/>
+            <a:ext cx="6766560" cy="512064"/>
+          </a:xfrm>
+          <a:prstGeom prst="rect">
+            <a:avLst/>
+          </a:prstGeom>
+          <a:noFill/>
+          <a:ln/>
+        </p:spPr>
+        <p:txBody>
+          <a:bodyPr wrap="square" lIns="0" tIns="0" rIns="0" bIns="0" rtlCol="0" anchor="ctr"/>
+          <a:lstStyle/>
+          <a:p>
             <a:pPr indent="0" marL="0">
               <a:buNone/>
             </a:pPr>
             <a:r>
-              <a:rPr lang="en-US" sz="1100" i="1" dirty="0">
-                <a:solidFill>
-                  <a:srgbClr val="5A6666"/>
+              <a:rPr lang="en-US" sz="1800" b="1" dirty="0">
+                <a:solidFill>
+                  <a:srgbClr val="0B2A4A"/>
                 </a:solidFill>
               </a:rPr>
-              <a:t>Nguồn: báo cáo Phòng Đào tạo và Phòng Kế hoạch – Tài chính, năm học 2025–2026</a:t>
-            </a:r>
-            <a:endParaRPr lang="en-US" sz="1100" dirty="0"/>
+              <a:t>Tồn tại và phương hướng</a:t>
+            </a:r>
+            <a:endParaRPr lang="en-US" sz="1800" dirty="0"/>
+          </a:p>
+        </p:txBody>
+      </p:sp>
+      <p:sp>
+        <p:nvSpPr>
+          <p:cNvPr id="25" name="Slide Number Placeholder 0"/>
+          <p:cNvSpPr>
+            <a:spLocks noGrp="1"/>
+          </p:cNvSpPr>
+          <p:nvPr>
+            <p:ph type="sldNum" sz="quarter" idx="4294967295"/>
+          </p:nvPr>
+        </p:nvSpPr>
+        <p:spPr>
+          <a:xfrm>
+            <a:off x="8138160" y="4727448"/>
+            <a:ext cx="457200" cy="274320"/>
+          </a:xfrm>
+          <a:prstGeom prst="rect">
+            <a:avLst/>
+          </a:prstGeom>
+          <a:extLst>
+            <a:ext uri="{C572A759-6A51-4108-AA02-DFA0A04FC94B}">
+              <ma14:wrappingTextBoxFlag xmlns:ma14="http://schemas.microsoft.com/office/mac/drawingml/2011/main" val="0"/>
+            </a:ext>
+          </a:extLst>
+        </p:spPr>
+        <p:txBody>
+          <a:bodyPr/>
+          <a:lstStyle>
+            <a:lvl1pPr>
+              <a:defRPr sz="1100">
+                <a:solidFill>
+                  <a:srgbClr val="6B7A90"/>
+                </a:solidFill>
+              </a:defRPr>
+            </a:lvl1pPr>
+          </a:lstStyle>
+          <a:p>
+            <a:pPr algn="r"/>
+            <a:fld id="{F7021451-1387-4CA6-816F-3879F97B5CBC}" type="slidenum">
+              <a:rPr b="0" lang="en-US"/>
+              <a:t>2</a:t>
+            </a:fld>
+            <a:endParaRPr lang="en-US"/>
           </a:p>
         </p:txBody>
       </p:sp>
@@ -3251,8 +4146,8 @@
         </p:nvSpPr>
         <p:spPr>
           <a:xfrm>
-            <a:off x="457200" y="274320"/>
-            <a:ext cx="8229600" cy="868680"/>
+            <a:off x="548640" y="274320"/>
+            <a:ext cx="8046720" cy="868680"/>
           </a:xfrm>
           <a:prstGeom prst="rect">
             <a:avLst/>
@@ -3270,41 +4165,101 @@
             <a:r>
               <a:rPr lang="en-US" sz="2800" b="1" dirty="0">
                 <a:solidFill>
-                  <a:srgbClr val="0F3D3E"/>
+                  <a:srgbClr val="0B2A4A"/>
                 </a:solidFill>
               </a:rPr>
-              <a:t>Ngành Luật nhập học thấp nhất so với chỉ tiêu</a:t>
+              <a:t>Nhập học đạt 91,2% chỉ tiêu, tổng thu 412.000 triệu đồng</a:t>
             </a:r>
             <a:endParaRPr lang="en-US" sz="2800" dirty="0"/>
           </a:p>
         </p:txBody>
       </p:sp>
-      <p:graphicFrame>
-        <p:nvGraphicFramePr>
-          <p:cNvPr id="4" name="bieu-do" descr=""/>
-          <p:cNvGraphicFramePr/>
-          <p:nvPr/>
-        </p:nvGraphicFramePr>
-        <p:xfrm>
-          <a:off x="457200" y="1234440"/>
-          <a:ext cx="8229600" cy="3291840"/>
-        </p:xfrm>
-        <a:graphic xmlns:a="http://schemas.openxmlformats.org/drawingml/2006/main">
-          <a:graphicData uri="http://schemas.openxmlformats.org/drawingml/2006/chart">
-            <c:chart xmlns:c="http://schemas.openxmlformats.org/drawingml/2006/chart" r:id="rId1"/>
-          </a:graphicData>
-        </a:graphic>
-      </p:graphicFrame>
-      <p:sp>
-        <p:nvSpPr>
-          <p:cNvPr id="5" name="nguon"/>
+      <p:sp>
+        <p:nvSpPr>
+          <p:cNvPr id="4" name="the"/>
+          <p:cNvSpPr/>
+          <p:nvPr/>
+        </p:nvSpPr>
+        <p:spPr>
+          <a:xfrm>
+            <a:off x="548640" y="1325880"/>
+            <a:ext cx="2560320" cy="2926080"/>
+          </a:xfrm>
+          <a:prstGeom prst="roundRect">
+            <a:avLst>
+              <a:gd name="adj" fmla="val 2857"/>
+            </a:avLst>
+          </a:prstGeom>
+          <a:solidFill>
+            <a:srgbClr val="F1F4F8"/>
+          </a:solidFill>
+          <a:ln w="12700">
+            <a:solidFill>
+              <a:srgbClr val="F1F4F8"/>
+            </a:solidFill>
+            <a:prstDash val="solid"/>
+          </a:ln>
+        </p:spPr>
+      </p:sp>
+      <p:sp>
+        <p:nvSpPr>
+          <p:cNvPr id="5" name="o-bieu-tuong"/>
+          <p:cNvSpPr/>
+          <p:nvPr/>
+        </p:nvSpPr>
+        <p:spPr>
+          <a:xfrm>
+            <a:off x="777240" y="1554480"/>
+            <a:ext cx="548640" cy="548640"/>
+          </a:xfrm>
+          <a:prstGeom prst="ellipse">
+            <a:avLst/>
+          </a:prstGeom>
+          <a:solidFill>
+            <a:srgbClr val="1F4E8C"/>
+          </a:solidFill>
+          <a:ln w="12700">
+            <a:solidFill>
+              <a:srgbClr val="1F4E8C"/>
+            </a:solidFill>
+            <a:prstDash val="solid"/>
+          </a:ln>
+        </p:spPr>
+      </p:sp>
+      <p:pic>
+        <p:nvPicPr>
+          <p:cNvPr id="6" name="bieu-tuong" descr="Biểu tượng minh họa">    </p:cNvPr>
+          <p:cNvPicPr>
+            <a:picLocks noChangeAspect="1"/>
+          </p:cNvPicPr>
+          <p:nvPr/>
+        </p:nvPicPr>
+        <p:blipFill>
+          <a:blip r:embed="rId1"/>
+          <a:stretch>
+            <a:fillRect/>
+          </a:stretch>
+        </p:blipFill>
+        <p:spPr>
+          <a:xfrm>
+            <a:off x="914400" y="1691640"/>
+            <a:ext cx="274320" cy="274320"/>
+          </a:xfrm>
+          <a:prstGeom prst="rect">
+            <a:avLst/>
+          </a:prstGeom>
+        </p:spPr>
+      </p:pic>
+      <p:sp>
+        <p:nvSpPr>
+          <p:cNvPr id="7" name="so-lieu"/>
           <p:cNvSpPr txBox="1"/>
           <p:nvPr/>
         </p:nvSpPr>
         <p:spPr>
           <a:xfrm>
-            <a:off x="457200" y="4617720"/>
-            <a:ext cx="8229600" cy="320040"/>
+            <a:off x="777240" y="2240280"/>
+            <a:ext cx="2103120" cy="777240"/>
           </a:xfrm>
           <a:prstGeom prst="rect">
             <a:avLst/>
@@ -3320,14 +4275,436 @@
               <a:buNone/>
             </a:pPr>
             <a:r>
+              <a:rPr lang="en-US" sz="4000" b="1" dirty="0">
+                <a:solidFill>
+                  <a:srgbClr val="1F4E8C"/>
+                </a:solidFill>
+                <a:latin typeface="Cambria" pitchFamily="34" charset="0"/>
+                <a:ea typeface="Cambria" pitchFamily="34" charset="-122"/>
+                <a:cs typeface="Cambria" pitchFamily="34" charset="-120"/>
+              </a:rPr>
+              <a:t>91,2%</a:t>
+            </a:r>
+            <a:endParaRPr lang="en-US" sz="4000" dirty="0"/>
+          </a:p>
+        </p:txBody>
+      </p:sp>
+      <p:sp>
+        <p:nvSpPr>
+          <p:cNvPr id="8" name="nhan"/>
+          <p:cNvSpPr txBox="1"/>
+          <p:nvPr/>
+        </p:nvSpPr>
+        <p:spPr>
+          <a:xfrm>
+            <a:off x="777240" y="3063240"/>
+            <a:ext cx="2103120" cy="1051560"/>
+          </a:xfrm>
+          <a:prstGeom prst="rect">
+            <a:avLst/>
+          </a:prstGeom>
+          <a:noFill/>
+          <a:ln/>
+        </p:spPr>
+        <p:txBody>
+          <a:bodyPr wrap="square" lIns="0" tIns="0" rIns="0" bIns="0" rtlCol="0" anchor="t"/>
+          <a:lstStyle/>
+          <a:p>
+            <a:pPr indent="0" marL="0">
+              <a:buNone/>
+            </a:pPr>
+            <a:r>
+              <a:rPr lang="en-US" sz="1600" dirty="0">
+                <a:solidFill>
+                  <a:srgbClr val="1A2433"/>
+                </a:solidFill>
+              </a:rPr>
+              <a:t>nhập học 1.642 trên chỉ tiêu 1.800</a:t>
+            </a:r>
+            <a:endParaRPr lang="en-US" sz="1600" dirty="0"/>
+          </a:p>
+        </p:txBody>
+      </p:sp>
+      <p:sp>
+        <p:nvSpPr>
+          <p:cNvPr id="9" name="the"/>
+          <p:cNvSpPr/>
+          <p:nvPr/>
+        </p:nvSpPr>
+        <p:spPr>
+          <a:xfrm>
+            <a:off x="3291840" y="1325880"/>
+            <a:ext cx="2560320" cy="2926080"/>
+          </a:xfrm>
+          <a:prstGeom prst="roundRect">
+            <a:avLst>
+              <a:gd name="adj" fmla="val 2857"/>
+            </a:avLst>
+          </a:prstGeom>
+          <a:solidFill>
+            <a:srgbClr val="F1F4F8"/>
+          </a:solidFill>
+          <a:ln w="12700">
+            <a:solidFill>
+              <a:srgbClr val="F1F4F8"/>
+            </a:solidFill>
+            <a:prstDash val="solid"/>
+          </a:ln>
+        </p:spPr>
+      </p:sp>
+      <p:sp>
+        <p:nvSpPr>
+          <p:cNvPr id="10" name="o-bieu-tuong"/>
+          <p:cNvSpPr/>
+          <p:nvPr/>
+        </p:nvSpPr>
+        <p:spPr>
+          <a:xfrm>
+            <a:off x="3520440" y="1554480"/>
+            <a:ext cx="548640" cy="548640"/>
+          </a:xfrm>
+          <a:prstGeom prst="ellipse">
+            <a:avLst/>
+          </a:prstGeom>
+          <a:solidFill>
+            <a:srgbClr val="2E7D6B"/>
+          </a:solidFill>
+          <a:ln w="12700">
+            <a:solidFill>
+              <a:srgbClr val="2E7D6B"/>
+            </a:solidFill>
+            <a:prstDash val="solid"/>
+          </a:ln>
+        </p:spPr>
+      </p:sp>
+      <p:pic>
+        <p:nvPicPr>
+          <p:cNvPr id="11" name="bieu-tuong" descr="Biểu tượng minh họa">    </p:cNvPr>
+          <p:cNvPicPr>
+            <a:picLocks noChangeAspect="1"/>
+          </p:cNvPicPr>
+          <p:nvPr/>
+        </p:nvPicPr>
+        <p:blipFill>
+          <a:blip r:embed="rId2"/>
+          <a:stretch>
+            <a:fillRect/>
+          </a:stretch>
+        </p:blipFill>
+        <p:spPr>
+          <a:xfrm>
+            <a:off x="3657600" y="1691640"/>
+            <a:ext cx="274320" cy="274320"/>
+          </a:xfrm>
+          <a:prstGeom prst="rect">
+            <a:avLst/>
+          </a:prstGeom>
+        </p:spPr>
+      </p:pic>
+      <p:sp>
+        <p:nvSpPr>
+          <p:cNvPr id="12" name="so-lieu"/>
+          <p:cNvSpPr txBox="1"/>
+          <p:nvPr/>
+        </p:nvSpPr>
+        <p:spPr>
+          <a:xfrm>
+            <a:off x="3520440" y="2240280"/>
+            <a:ext cx="2103120" cy="777240"/>
+          </a:xfrm>
+          <a:prstGeom prst="rect">
+            <a:avLst/>
+          </a:prstGeom>
+          <a:noFill/>
+          <a:ln/>
+        </p:spPr>
+        <p:txBody>
+          <a:bodyPr wrap="square" lIns="0" tIns="0" rIns="0" bIns="0" rtlCol="0" anchor="ctr"/>
+          <a:lstStyle/>
+          <a:p>
+            <a:pPr indent="0" marL="0">
+              <a:buNone/>
+            </a:pPr>
+            <a:r>
+              <a:rPr lang="en-US" sz="4000" b="1" dirty="0">
+                <a:solidFill>
+                  <a:srgbClr val="2E7D6B"/>
+                </a:solidFill>
+                <a:latin typeface="Cambria" pitchFamily="34" charset="0"/>
+                <a:ea typeface="Cambria" pitchFamily="34" charset="-122"/>
+                <a:cs typeface="Cambria" pitchFamily="34" charset="-120"/>
+              </a:rPr>
+              <a:t>84%</a:t>
+            </a:r>
+            <a:endParaRPr lang="en-US" sz="4000" dirty="0"/>
+          </a:p>
+        </p:txBody>
+      </p:sp>
+      <p:sp>
+        <p:nvSpPr>
+          <p:cNvPr id="13" name="nhan"/>
+          <p:cNvSpPr txBox="1"/>
+          <p:nvPr/>
+        </p:nvSpPr>
+        <p:spPr>
+          <a:xfrm>
+            <a:off x="3520440" y="3063240"/>
+            <a:ext cx="2103120" cy="1051560"/>
+          </a:xfrm>
+          <a:prstGeom prst="rect">
+            <a:avLst/>
+          </a:prstGeom>
+          <a:noFill/>
+          <a:ln/>
+        </p:spPr>
+        <p:txBody>
+          <a:bodyPr wrap="square" lIns="0" tIns="0" rIns="0" bIns="0" rtlCol="0" anchor="t"/>
+          <a:lstStyle/>
+          <a:p>
+            <a:pPr indent="0" marL="0">
+              <a:buNone/>
+            </a:pPr>
+            <a:r>
+              <a:rPr lang="en-US" sz="1600" dirty="0">
+                <a:solidFill>
+                  <a:srgbClr val="1A2433"/>
+                </a:solidFill>
+              </a:rPr>
+              <a:t>tốt nghiệp đúng hạn, năm học 2024–2025 (năm gần nhất có số liệu)</a:t>
+            </a:r>
+            <a:endParaRPr lang="en-US" sz="1600" dirty="0"/>
+          </a:p>
+        </p:txBody>
+      </p:sp>
+      <p:sp>
+        <p:nvSpPr>
+          <p:cNvPr id="14" name="the"/>
+          <p:cNvSpPr/>
+          <p:nvPr/>
+        </p:nvSpPr>
+        <p:spPr>
+          <a:xfrm>
+            <a:off x="6035040" y="1325880"/>
+            <a:ext cx="2560320" cy="2926080"/>
+          </a:xfrm>
+          <a:prstGeom prst="roundRect">
+            <a:avLst>
+              <a:gd name="adj" fmla="val 2857"/>
+            </a:avLst>
+          </a:prstGeom>
+          <a:solidFill>
+            <a:srgbClr val="F1F4F8"/>
+          </a:solidFill>
+          <a:ln w="12700">
+            <a:solidFill>
+              <a:srgbClr val="F1F4F8"/>
+            </a:solidFill>
+            <a:prstDash val="solid"/>
+          </a:ln>
+        </p:spPr>
+      </p:sp>
+      <p:sp>
+        <p:nvSpPr>
+          <p:cNvPr id="15" name="o-bieu-tuong"/>
+          <p:cNvSpPr/>
+          <p:nvPr/>
+        </p:nvSpPr>
+        <p:spPr>
+          <a:xfrm>
+            <a:off x="6263640" y="1554480"/>
+            <a:ext cx="548640" cy="548640"/>
+          </a:xfrm>
+          <a:prstGeom prst="ellipse">
+            <a:avLst/>
+          </a:prstGeom>
+          <a:solidFill>
+            <a:srgbClr val="B8902B"/>
+          </a:solidFill>
+          <a:ln w="12700">
+            <a:solidFill>
+              <a:srgbClr val="B8902B"/>
+            </a:solidFill>
+            <a:prstDash val="solid"/>
+          </a:ln>
+        </p:spPr>
+      </p:sp>
+      <p:pic>
+        <p:nvPicPr>
+          <p:cNvPr id="16" name="bieu-tuong" descr="Biểu tượng minh họa">    </p:cNvPr>
+          <p:cNvPicPr>
+            <a:picLocks noChangeAspect="1"/>
+          </p:cNvPicPr>
+          <p:nvPr/>
+        </p:nvPicPr>
+        <p:blipFill>
+          <a:blip r:embed="rId3"/>
+          <a:stretch>
+            <a:fillRect/>
+          </a:stretch>
+        </p:blipFill>
+        <p:spPr>
+          <a:xfrm>
+            <a:off x="6400800" y="1691640"/>
+            <a:ext cx="274320" cy="274320"/>
+          </a:xfrm>
+          <a:prstGeom prst="rect">
+            <a:avLst/>
+          </a:prstGeom>
+        </p:spPr>
+      </p:pic>
+      <p:sp>
+        <p:nvSpPr>
+          <p:cNvPr id="17" name="so-lieu"/>
+          <p:cNvSpPr txBox="1"/>
+          <p:nvPr/>
+        </p:nvSpPr>
+        <p:spPr>
+          <a:xfrm>
+            <a:off x="6263640" y="2240280"/>
+            <a:ext cx="2103120" cy="777240"/>
+          </a:xfrm>
+          <a:prstGeom prst="rect">
+            <a:avLst/>
+          </a:prstGeom>
+          <a:noFill/>
+          <a:ln/>
+        </p:spPr>
+        <p:txBody>
+          <a:bodyPr wrap="square" lIns="0" tIns="0" rIns="0" bIns="0" rtlCol="0" anchor="ctr"/>
+          <a:lstStyle/>
+          <a:p>
+            <a:pPr indent="0" marL="0">
+              <a:buNone/>
+            </a:pPr>
+            <a:r>
+              <a:rPr lang="en-US" sz="4000" b="1" dirty="0">
+                <a:solidFill>
+                  <a:srgbClr val="B8902B"/>
+                </a:solidFill>
+                <a:latin typeface="Cambria" pitchFamily="34" charset="0"/>
+                <a:ea typeface="Cambria" pitchFamily="34" charset="-122"/>
+                <a:cs typeface="Cambria" pitchFamily="34" charset="-120"/>
+              </a:rPr>
+              <a:t>412.000</a:t>
+            </a:r>
+            <a:endParaRPr lang="en-US" sz="4000" dirty="0"/>
+          </a:p>
+        </p:txBody>
+      </p:sp>
+      <p:sp>
+        <p:nvSpPr>
+          <p:cNvPr id="18" name="nhan"/>
+          <p:cNvSpPr txBox="1"/>
+          <p:nvPr/>
+        </p:nvSpPr>
+        <p:spPr>
+          <a:xfrm>
+            <a:off x="6263640" y="3063240"/>
+            <a:ext cx="2103120" cy="1051560"/>
+          </a:xfrm>
+          <a:prstGeom prst="rect">
+            <a:avLst/>
+          </a:prstGeom>
+          <a:noFill/>
+          <a:ln/>
+        </p:spPr>
+        <p:txBody>
+          <a:bodyPr wrap="square" lIns="0" tIns="0" rIns="0" bIns="0" rtlCol="0" anchor="t"/>
+          <a:lstStyle/>
+          <a:p>
+            <a:pPr indent="0" marL="0">
+              <a:buNone/>
+            </a:pPr>
+            <a:r>
+              <a:rPr lang="en-US" sz="1600" dirty="0">
+                <a:solidFill>
+                  <a:srgbClr val="1A2433"/>
+                </a:solidFill>
+              </a:rPr>
+              <a:t>triệu đồng tổng thu năm học</a:t>
+            </a:r>
+            <a:endParaRPr lang="en-US" sz="1600" dirty="0"/>
+          </a:p>
+        </p:txBody>
+      </p:sp>
+      <p:sp>
+        <p:nvSpPr>
+          <p:cNvPr id="19" name="nguon"/>
+          <p:cNvSpPr txBox="1"/>
+          <p:nvPr/>
+        </p:nvSpPr>
+        <p:spPr>
+          <a:xfrm>
+            <a:off x="548640" y="4416552"/>
+            <a:ext cx="8046720" cy="274320"/>
+          </a:xfrm>
+          <a:prstGeom prst="rect">
+            <a:avLst/>
+          </a:prstGeom>
+          <a:noFill/>
+          <a:ln/>
+        </p:spPr>
+        <p:txBody>
+          <a:bodyPr wrap="square" lIns="0" tIns="0" rIns="0" bIns="0" rtlCol="0" anchor="ctr"/>
+          <a:lstStyle/>
+          <a:p>
+            <a:pPr indent="0" marL="0">
+              <a:buNone/>
+            </a:pPr>
+            <a:r>
               <a:rPr lang="en-US" sz="1100" i="1" dirty="0">
                 <a:solidFill>
-                  <a:srgbClr val="5A6666"/>
+                  <a:srgbClr val="6B7A90"/>
                 </a:solidFill>
               </a:rPr>
-              <a:t>Nguồn: báo cáo Phòng Đào tạo, năm học 2025–2026</a:t>
+              <a:t>Nguồn: báo cáo Phòng Đào tạo và Phòng Kế hoạch – Tài chính, năm học 2025–2026</a:t>
             </a:r>
             <a:endParaRPr lang="en-US" sz="1100" dirty="0"/>
+          </a:p>
+        </p:txBody>
+      </p:sp>
+      <p:sp>
+        <p:nvSpPr>
+          <p:cNvPr id="25" name="Slide Number Placeholder 0"/>
+          <p:cNvSpPr>
+            <a:spLocks noGrp="1"/>
+          </p:cNvSpPr>
+          <p:nvPr>
+            <p:ph type="sldNum" sz="quarter" idx="4294967295"/>
+          </p:nvPr>
+        </p:nvSpPr>
+        <p:spPr>
+          <a:xfrm>
+            <a:off x="8138160" y="4727448"/>
+            <a:ext cx="457200" cy="274320"/>
+          </a:xfrm>
+          <a:prstGeom prst="rect">
+            <a:avLst/>
+          </a:prstGeom>
+          <a:extLst>
+            <a:ext uri="{C572A759-6A51-4108-AA02-DFA0A04FC94B}">
+              <ma14:wrappingTextBoxFlag xmlns:ma14="http://schemas.microsoft.com/office/mac/drawingml/2011/main" val="0"/>
+            </a:ext>
+          </a:extLst>
+        </p:spPr>
+        <p:txBody>
+          <a:bodyPr/>
+          <a:lstStyle>
+            <a:lvl1pPr>
+              <a:defRPr sz="1100">
+                <a:solidFill>
+                  <a:srgbClr val="6B7A90"/>
+                </a:solidFill>
+              </a:defRPr>
+            </a:lvl1pPr>
+          </a:lstStyle>
+          <a:p>
+            <a:pPr algn="r"/>
+            <a:fld id="{F7021451-1387-4CA6-816F-3879F97B5CBC}" type="slidenum">
+              <a:rPr b="0" lang="en-US"/>
+              <a:t>3</a:t>
+            </a:fld>
+            <a:endParaRPr lang="en-US"/>
           </a:p>
         </p:txBody>
       </p:sp>
@@ -3366,8 +4743,8 @@
         </p:nvSpPr>
         <p:spPr>
           <a:xfrm>
-            <a:off x="457200" y="274320"/>
-            <a:ext cx="8229600" cy="868680"/>
+            <a:off x="548640" y="274320"/>
+            <a:ext cx="8046720" cy="868680"/>
           </a:xfrm>
           <a:prstGeom prst="rect">
             <a:avLst/>
@@ -3385,10 +4762,10 @@
             <a:r>
               <a:rPr lang="en-US" sz="2800" b="1" dirty="0">
                 <a:solidFill>
-                  <a:srgbClr val="0F3D3E"/>
+                  <a:srgbClr val="0B2A4A"/>
                 </a:solidFill>
               </a:rPr>
-              <a:t>Tốt nghiệp đúng hạn tăng 6 điểm phần trăm sau hai năm</a:t>
+              <a:t>Luật có tỷ lệ nhập học thấp nhất trong bốn ngành</a:t>
             </a:r>
             <a:endParaRPr lang="en-US" sz="2800" dirty="0"/>
           </a:p>
@@ -3401,8 +4778,8 @@
           <p:nvPr/>
         </p:nvGraphicFramePr>
         <p:xfrm>
-          <a:off x="457200" y="1234440"/>
-          <a:ext cx="5669280" cy="3291840"/>
+          <a:off x="548640" y="1234440"/>
+          <a:ext cx="5394960" cy="3154680"/>
         </p:xfrm>
         <a:graphic xmlns:a="http://schemas.openxmlformats.org/drawingml/2006/main">
           <a:graphicData uri="http://schemas.openxmlformats.org/drawingml/2006/chart">
@@ -3412,14 +4789,65 @@
       </p:graphicFrame>
       <p:sp>
         <p:nvSpPr>
-          <p:cNvPr id="5" name="ghi-chu"/>
+          <p:cNvPr id="5" name="nhan-xet"/>
+          <p:cNvSpPr/>
+          <p:nvPr/>
+        </p:nvSpPr>
+        <p:spPr>
+          <a:xfrm>
+            <a:off x="6172200" y="1325880"/>
+            <a:ext cx="2423160" cy="3017520"/>
+          </a:xfrm>
+          <a:prstGeom prst="roundRect">
+            <a:avLst>
+              <a:gd name="adj" fmla="val 3019"/>
+            </a:avLst>
+          </a:prstGeom>
+          <a:solidFill>
+            <a:srgbClr val="F1F4F8"/>
+          </a:solidFill>
+          <a:ln w="12700">
+            <a:solidFill>
+              <a:srgbClr val="F1F4F8"/>
+            </a:solidFill>
+            <a:prstDash val="solid"/>
+          </a:ln>
+        </p:spPr>
+      </p:sp>
+      <p:pic>
+        <p:nvPicPr>
+          <p:cNvPr id="6" name="bieu-tuong" descr="Biểu tượng">    </p:cNvPr>
+          <p:cNvPicPr>
+            <a:picLocks noChangeAspect="1"/>
+          </p:cNvPicPr>
+          <p:nvPr/>
+        </p:nvPicPr>
+        <p:blipFill>
+          <a:blip r:embed="rId2"/>
+          <a:stretch>
+            <a:fillRect/>
+          </a:stretch>
+        </p:blipFill>
+        <p:spPr>
+          <a:xfrm>
+            <a:off x="6355080" y="1527048"/>
+            <a:ext cx="274320" cy="274320"/>
+          </a:xfrm>
+          <a:prstGeom prst="rect">
+            <a:avLst/>
+          </a:prstGeom>
+        </p:spPr>
+      </p:pic>
+      <p:sp>
+        <p:nvSpPr>
+          <p:cNvPr id="7" name="nhan-xet-tieu-de"/>
           <p:cNvSpPr txBox="1"/>
           <p:nvPr/>
         </p:nvSpPr>
         <p:spPr>
           <a:xfrm>
-            <a:off x="6400800" y="1737360"/>
-            <a:ext cx="2286000" cy="1463040"/>
+            <a:off x="6720840" y="1508760"/>
+            <a:ext cx="1691640" cy="329184"/>
           </a:xfrm>
           <a:prstGeom prst="rect">
             <a:avLst/>
@@ -3428,7 +4856,7 @@
           <a:ln/>
         </p:spPr>
         <p:txBody>
-          <a:bodyPr wrap="square" lIns="0" tIns="0" rIns="0" bIns="0" rtlCol="0" anchor="t"/>
+          <a:bodyPr wrap="square" lIns="0" tIns="0" rIns="0" bIns="0" rtlCol="0" anchor="ctr"/>
           <a:lstStyle/>
           <a:p>
             <a:pPr indent="0" marL="0">
@@ -3437,62 +4865,151 @@
             <a:r>
               <a:rPr lang="en-US" sz="1800" b="1" dirty="0">
                 <a:solidFill>
-                  <a:srgbClr val="1B1F2A"/>
+                  <a:srgbClr val="0B2A4A"/>
                 </a:solidFill>
               </a:rPr>
-              <a:t>2025–2026</a:t>
+              <a:t>Nhận xét</a:t>
             </a:r>
             <a:endParaRPr lang="en-US" sz="1800" dirty="0"/>
           </a:p>
+        </p:txBody>
+      </p:sp>
+      <p:sp>
+        <p:nvSpPr>
+          <p:cNvPr id="8" name="nhan-xet-chu"/>
+          <p:cNvSpPr txBox="1"/>
+          <p:nvPr/>
+        </p:nvSpPr>
+        <p:spPr>
+          <a:xfrm>
+            <a:off x="6355080" y="1965960"/>
+            <a:ext cx="2057400" cy="2286000"/>
+          </a:xfrm>
+          <a:prstGeom prst="rect">
+            <a:avLst/>
+          </a:prstGeom>
+          <a:noFill/>
+          <a:ln/>
+        </p:spPr>
+        <p:txBody>
+          <a:bodyPr wrap="square" lIns="0" tIns="0" rIns="0" bIns="0" rtlCol="0" anchor="t"/>
+          <a:lstStyle/>
+          <a:p>
+            <a:pPr marL="342900" indent="-342900">
+              <a:spcAft>
+                <a:spcPts val="800"/>
+              </a:spcAft>
+              <a:buSzPct val="100000"/>
+              <a:buChar char="•"/>
+            </a:pPr>
+            <a:r>
+              <a:rPr lang="en-US" sz="1600" dirty="0">
+                <a:solidFill>
+                  <a:srgbClr val="1A2433"/>
+                </a:solidFill>
+              </a:rPr>
+              <a:t>Luật đạt 85,7% chỉ tiêu, thấp nhất</a:t>
+            </a:r>
+            <a:endParaRPr lang="en-US" sz="1600" dirty="0"/>
+          </a:p>
+          <a:p>
+            <a:pPr marL="342900" indent="-342900">
+              <a:spcAft>
+                <a:spcPts val="800"/>
+              </a:spcAft>
+              <a:buSzPct val="100000"/>
+              <a:buChar char="•"/>
+            </a:pPr>
+            <a:r>
+              <a:rPr lang="en-US" sz="1600" dirty="0">
+                <a:solidFill>
+                  <a:srgbClr val="1A2433"/>
+                </a:solidFill>
+              </a:rPr>
+              <a:t>Công nghệ thông tin đạt 95,2%, cao nhất</a:t>
+            </a:r>
+            <a:endParaRPr lang="en-US" sz="1600" dirty="0"/>
+          </a:p>
+        </p:txBody>
+      </p:sp>
+      <p:sp>
+        <p:nvSpPr>
+          <p:cNvPr id="9" name="nguon"/>
+          <p:cNvSpPr txBox="1"/>
+          <p:nvPr/>
+        </p:nvSpPr>
+        <p:spPr>
+          <a:xfrm>
+            <a:off x="548640" y="4416552"/>
+            <a:ext cx="8046720" cy="274320"/>
+          </a:xfrm>
+          <a:prstGeom prst="rect">
+            <a:avLst/>
+          </a:prstGeom>
+          <a:noFill/>
+          <a:ln/>
+        </p:spPr>
+        <p:txBody>
+          <a:bodyPr wrap="square" lIns="0" tIns="0" rIns="0" bIns="0" rtlCol="0" anchor="ctr"/>
+          <a:lstStyle/>
           <a:p>
             <a:pPr indent="0" marL="0">
               <a:buNone/>
             </a:pPr>
             <a:r>
-              <a:rPr lang="en-US" sz="1600" dirty="0">
-                <a:solidFill>
-                  <a:srgbClr val="1B1F2A"/>
+              <a:rPr lang="en-US" sz="1100" i="1" dirty="0">
+                <a:solidFill>
+                  <a:srgbClr val="6B7A90"/>
                 </a:solidFill>
               </a:rPr>
-              <a:t>Chưa có số liệu: năm học chưa xét tốt nghiệp</a:t>
-            </a:r>
-            <a:endParaRPr lang="en-US" sz="1800" dirty="0"/>
-          </a:p>
-        </p:txBody>
-      </p:sp>
-      <p:sp>
-        <p:nvSpPr>
-          <p:cNvPr id="6" name="nguon"/>
-          <p:cNvSpPr txBox="1"/>
-          <p:nvPr/>
-        </p:nvSpPr>
-        <p:spPr>
-          <a:xfrm>
-            <a:off x="457200" y="4617720"/>
-            <a:ext cx="8229600" cy="320040"/>
-          </a:xfrm>
-          <a:prstGeom prst="rect">
-            <a:avLst/>
-          </a:prstGeom>
-          <a:noFill/>
-          <a:ln/>
-        </p:spPr>
-        <p:txBody>
-          <a:bodyPr wrap="square" lIns="0" tIns="0" rIns="0" bIns="0" rtlCol="0" anchor="ctr"/>
-          <a:lstStyle/>
-          <a:p>
-            <a:pPr indent="0" marL="0">
-              <a:buNone/>
-            </a:pPr>
-            <a:r>
-              <a:rPr lang="en-US" sz="1100" i="1" dirty="0">
-                <a:solidFill>
-                  <a:srgbClr val="5A6666"/>
-                </a:solidFill>
-              </a:rPr>
-              <a:t>Nguồn: báo cáo Phòng Đào tạo. Năm học 2025–2026 chưa có số liệu</a:t>
+              <a:t>Nguồn: báo cáo Phòng Đào tạo, năm học 2025–2026</a:t>
             </a:r>
             <a:endParaRPr lang="en-US" sz="1100" dirty="0"/>
+          </a:p>
+        </p:txBody>
+      </p:sp>
+      <p:sp>
+        <p:nvSpPr>
+          <p:cNvPr id="25" name="Slide Number Placeholder 0"/>
+          <p:cNvSpPr>
+            <a:spLocks noGrp="1"/>
+          </p:cNvSpPr>
+          <p:nvPr>
+            <p:ph type="sldNum" sz="quarter" idx="4294967295"/>
+          </p:nvPr>
+        </p:nvSpPr>
+        <p:spPr>
+          <a:xfrm>
+            <a:off x="8138160" y="4727448"/>
+            <a:ext cx="457200" cy="274320"/>
+          </a:xfrm>
+          <a:prstGeom prst="rect">
+            <a:avLst/>
+          </a:prstGeom>
+          <a:extLst>
+            <a:ext uri="{C572A759-6A51-4108-AA02-DFA0A04FC94B}">
+              <ma14:wrappingTextBoxFlag xmlns:ma14="http://schemas.microsoft.com/office/mac/drawingml/2011/main" val="0"/>
+            </a:ext>
+          </a:extLst>
+        </p:spPr>
+        <p:txBody>
+          <a:bodyPr/>
+          <a:lstStyle>
+            <a:lvl1pPr>
+              <a:defRPr sz="1100">
+                <a:solidFill>
+                  <a:srgbClr val="6B7A90"/>
+                </a:solidFill>
+              </a:defRPr>
+            </a:lvl1pPr>
+          </a:lstStyle>
+          <a:p>
+            <a:pPr algn="r"/>
+            <a:fld id="{F7021451-1387-4CA6-816F-3879F97B5CBC}" type="slidenum">
+              <a:rPr b="0" lang="en-US"/>
+              <a:t>4</a:t>
+            </a:fld>
+            <a:endParaRPr lang="en-US"/>
           </a:p>
         </p:txBody>
       </p:sp>
@@ -3531,8 +5048,8 @@
         </p:nvSpPr>
         <p:spPr>
           <a:xfrm>
-            <a:off x="457200" y="274320"/>
-            <a:ext cx="8229600" cy="868680"/>
+            <a:off x="548640" y="274320"/>
+            <a:ext cx="8046720" cy="868680"/>
           </a:xfrm>
           <a:prstGeom prst="rect">
             <a:avLst/>
@@ -3550,10 +5067,10 @@
             <a:r>
               <a:rPr lang="en-US" sz="2800" b="1" dirty="0">
                 <a:solidFill>
-                  <a:srgbClr val="0F3D3E"/>
+                  <a:srgbClr val="0B2A4A"/>
                 </a:solidFill>
               </a:rPr>
-              <a:t>Lương và phụ cấp chiếm hơn một nửa chi</a:t>
+              <a:t>Tốt nghiệp đúng hạn tăng 6 điểm phần trăm sau hai năm</a:t>
             </a:r>
             <a:endParaRPr lang="en-US" sz="2800" dirty="0"/>
           </a:p>
@@ -3566,8 +5083,8 @@
           <p:nvPr/>
         </p:nvGraphicFramePr>
         <p:xfrm>
-          <a:off x="457200" y="1234440"/>
-          <a:ext cx="5486400" cy="3291840"/>
+          <a:off x="548640" y="1234440"/>
+          <a:ext cx="5394960" cy="3154680"/>
         </p:xfrm>
         <a:graphic xmlns:a="http://schemas.openxmlformats.org/drawingml/2006/main">
           <a:graphicData uri="http://schemas.openxmlformats.org/drawingml/2006/chart">
@@ -3577,41 +5094,65 @@
       </p:graphicFrame>
       <p:sp>
         <p:nvSpPr>
-          <p:cNvPr id="5" name="luu-y"/>
+          <p:cNvPr id="5" name="nhan-xet"/>
           <p:cNvSpPr/>
           <p:nvPr/>
         </p:nvSpPr>
         <p:spPr>
           <a:xfrm>
-            <a:off x="6217920" y="1737360"/>
-            <a:ext cx="2468880" cy="1920240"/>
+            <a:off x="6172200" y="1325880"/>
+            <a:ext cx="2423160" cy="3017520"/>
           </a:xfrm>
           <a:prstGeom prst="roundRect">
             <a:avLst>
-              <a:gd name="adj" fmla="val 4762"/>
+              <a:gd name="adj" fmla="val 3019"/>
             </a:avLst>
           </a:prstGeom>
           <a:solidFill>
-            <a:srgbClr val="FBEEDD"/>
+            <a:srgbClr val="F1F4F8"/>
           </a:solidFill>
           <a:ln w="12700">
             <a:solidFill>
-              <a:srgbClr val="D9822B"/>
+              <a:srgbClr val="F1F4F8"/>
             </a:solidFill>
             <a:prstDash val="solid"/>
           </a:ln>
         </p:spPr>
       </p:sp>
-      <p:sp>
-        <p:nvSpPr>
-          <p:cNvPr id="6" name="luu-y-chu"/>
+      <p:pic>
+        <p:nvPicPr>
+          <p:cNvPr id="6" name="bieu-tuong" descr="Biểu tượng">    </p:cNvPr>
+          <p:cNvPicPr>
+            <a:picLocks noChangeAspect="1"/>
+          </p:cNvPicPr>
+          <p:nvPr/>
+        </p:nvPicPr>
+        <p:blipFill>
+          <a:blip r:embed="rId2"/>
+          <a:stretch>
+            <a:fillRect/>
+          </a:stretch>
+        </p:blipFill>
+        <p:spPr>
+          <a:xfrm>
+            <a:off x="6355080" y="1527048"/>
+            <a:ext cx="274320" cy="274320"/>
+          </a:xfrm>
+          <a:prstGeom prst="rect">
+            <a:avLst/>
+          </a:prstGeom>
+        </p:spPr>
+      </p:pic>
+      <p:sp>
+        <p:nvSpPr>
+          <p:cNvPr id="7" name="nhan-xet-tieu-de"/>
           <p:cNvSpPr txBox="1"/>
           <p:nvPr/>
         </p:nvSpPr>
         <p:spPr>
           <a:xfrm>
-            <a:off x="6355080" y="1828800"/>
-            <a:ext cx="2194560" cy="1737360"/>
+            <a:off x="6720840" y="1508760"/>
+            <a:ext cx="1691640" cy="329184"/>
           </a:xfrm>
           <a:prstGeom prst="rect">
             <a:avLst/>
@@ -3620,71 +5161,160 @@
           <a:ln/>
         </p:spPr>
         <p:txBody>
-          <a:bodyPr wrap="square" lIns="0" tIns="0" rIns="0" bIns="0" rtlCol="0" anchor="t"/>
+          <a:bodyPr wrap="square" lIns="0" tIns="0" rIns="0" bIns="0" rtlCol="0" anchor="ctr"/>
           <a:lstStyle/>
           <a:p>
             <a:pPr indent="0" marL="0">
               <a:buNone/>
             </a:pPr>
             <a:r>
-              <a:rPr lang="en-US" sz="1600" b="1" dirty="0">
-                <a:solidFill>
-                  <a:srgbClr val="1B1F2A"/>
+              <a:rPr lang="en-US" sz="1800" b="1" dirty="0">
+                <a:solidFill>
+                  <a:srgbClr val="0B2A4A"/>
                 </a:solidFill>
               </a:rPr>
-              <a:t>Cần rà lại</a:t>
+              <a:t>Lưu ý</a:t>
+            </a:r>
+            <a:endParaRPr lang="en-US" sz="1800" dirty="0"/>
+          </a:p>
+        </p:txBody>
+      </p:sp>
+      <p:sp>
+        <p:nvSpPr>
+          <p:cNvPr id="8" name="nhan-xet-chu"/>
+          <p:cNvSpPr txBox="1"/>
+          <p:nvPr/>
+        </p:nvSpPr>
+        <p:spPr>
+          <a:xfrm>
+            <a:off x="6355080" y="1965960"/>
+            <a:ext cx="2057400" cy="2286000"/>
+          </a:xfrm>
+          <a:prstGeom prst="rect">
+            <a:avLst/>
+          </a:prstGeom>
+          <a:noFill/>
+          <a:ln/>
+        </p:spPr>
+        <p:txBody>
+          <a:bodyPr wrap="square" lIns="0" tIns="0" rIns="0" bIns="0" rtlCol="0" anchor="t"/>
+          <a:lstStyle/>
+          <a:p>
+            <a:pPr marL="342900" indent="-342900">
+              <a:spcAft>
+                <a:spcPts val="800"/>
+              </a:spcAft>
+              <a:buSzPct val="100000"/>
+              <a:buChar char="•"/>
+            </a:pPr>
+            <a:r>
+              <a:rPr lang="en-US" sz="1600" dirty="0">
+                <a:solidFill>
+                  <a:srgbClr val="1A2433"/>
+                </a:solidFill>
+              </a:rPr>
+              <a:t>Tăng 6 điểm phần trăm so với 2022–2023</a:t>
             </a:r>
             <a:endParaRPr lang="en-US" sz="1600" dirty="0"/>
           </a:p>
+          <a:p>
+            <a:pPr marL="342900" indent="-342900">
+              <a:spcAft>
+                <a:spcPts val="800"/>
+              </a:spcAft>
+              <a:buSzPct val="100000"/>
+              <a:buChar char="•"/>
+            </a:pPr>
+            <a:r>
+              <a:rPr lang="en-US" sz="1600" dirty="0">
+                <a:solidFill>
+                  <a:srgbClr val="1A2433"/>
+                </a:solidFill>
+              </a:rPr>
+              <a:t>2025–2026: chưa có số liệu vì chưa xét tốt nghiệp</a:t>
+            </a:r>
+            <a:endParaRPr lang="en-US" sz="1600" dirty="0"/>
+          </a:p>
+        </p:txBody>
+      </p:sp>
+      <p:sp>
+        <p:nvSpPr>
+          <p:cNvPr id="9" name="nguon"/>
+          <p:cNvSpPr txBox="1"/>
+          <p:nvPr/>
+        </p:nvSpPr>
+        <p:spPr>
+          <a:xfrm>
+            <a:off x="548640" y="4416552"/>
+            <a:ext cx="8046720" cy="274320"/>
+          </a:xfrm>
+          <a:prstGeom prst="rect">
+            <a:avLst/>
+          </a:prstGeom>
+          <a:noFill/>
+          <a:ln/>
+        </p:spPr>
+        <p:txBody>
+          <a:bodyPr wrap="square" lIns="0" tIns="0" rIns="0" bIns="0" rtlCol="0" anchor="ctr"/>
+          <a:lstStyle/>
           <a:p>
             <a:pPr indent="0" marL="0">
               <a:buNone/>
             </a:pPr>
             <a:r>
-              <a:rPr lang="en-US" sz="1400" dirty="0">
-                <a:solidFill>
-                  <a:srgbClr val="1B1F2A"/>
+              <a:rPr lang="en-US" sz="1100" i="1" dirty="0">
+                <a:solidFill>
+                  <a:srgbClr val="6B7A90"/>
                 </a:solidFill>
               </a:rPr>
-              <a:t>Cộng các nhóm: 398.500. Báo cáo khai: 400.000.</a:t>
-            </a:r>
-            <a:endParaRPr lang="en-US" sz="1600" dirty="0"/>
-          </a:p>
-        </p:txBody>
-      </p:sp>
-      <p:sp>
-        <p:nvSpPr>
-          <p:cNvPr id="7" name="nguon"/>
-          <p:cNvSpPr txBox="1"/>
-          <p:nvPr/>
-        </p:nvSpPr>
-        <p:spPr>
-          <a:xfrm>
-            <a:off x="457200" y="4617720"/>
-            <a:ext cx="8229600" cy="320040"/>
-          </a:xfrm>
-          <a:prstGeom prst="rect">
-            <a:avLst/>
-          </a:prstGeom>
-          <a:noFill/>
-          <a:ln/>
-        </p:spPr>
-        <p:txBody>
-          <a:bodyPr wrap="square" lIns="0" tIns="0" rIns="0" bIns="0" rtlCol="0" anchor="ctr"/>
-          <a:lstStyle/>
-          <a:p>
-            <a:pPr indent="0" marL="0">
-              <a:buNone/>
-            </a:pPr>
-            <a:r>
-              <a:rPr lang="en-US" sz="1100" i="1" dirty="0">
-                <a:solidFill>
-                  <a:srgbClr val="5A6666"/>
-                </a:solidFill>
-              </a:rPr>
-              <a:t>Nguồn: báo cáo Phòng Kế hoạch – Tài chính, năm học 2025–2026 (đơn vị: triệu đồng)</a:t>
+              <a:t>Nguồn: báo cáo Phòng Đào tạo. Năm học 2025–2026 chưa có số liệu</a:t>
             </a:r>
             <a:endParaRPr lang="en-US" sz="1100" dirty="0"/>
+          </a:p>
+        </p:txBody>
+      </p:sp>
+      <p:sp>
+        <p:nvSpPr>
+          <p:cNvPr id="25" name="Slide Number Placeholder 0"/>
+          <p:cNvSpPr>
+            <a:spLocks noGrp="1"/>
+          </p:cNvSpPr>
+          <p:nvPr>
+            <p:ph type="sldNum" sz="quarter" idx="4294967295"/>
+          </p:nvPr>
+        </p:nvSpPr>
+        <p:spPr>
+          <a:xfrm>
+            <a:off x="8138160" y="4727448"/>
+            <a:ext cx="457200" cy="274320"/>
+          </a:xfrm>
+          <a:prstGeom prst="rect">
+            <a:avLst/>
+          </a:prstGeom>
+          <a:extLst>
+            <a:ext uri="{C572A759-6A51-4108-AA02-DFA0A04FC94B}">
+              <ma14:wrappingTextBoxFlag xmlns:ma14="http://schemas.microsoft.com/office/mac/drawingml/2011/main" val="0"/>
+            </a:ext>
+          </a:extLst>
+        </p:spPr>
+        <p:txBody>
+          <a:bodyPr/>
+          <a:lstStyle>
+            <a:lvl1pPr>
+              <a:defRPr sz="1100">
+                <a:solidFill>
+                  <a:srgbClr val="6B7A90"/>
+                </a:solidFill>
+              </a:defRPr>
+            </a:lvl1pPr>
+          </a:lstStyle>
+          <a:p>
+            <a:pPr algn="r"/>
+            <a:fld id="{F7021451-1387-4CA6-816F-3879F97B5CBC}" type="slidenum">
+              <a:rPr b="0" lang="en-US"/>
+              <a:t>5</a:t>
+            </a:fld>
+            <a:endParaRPr lang="en-US"/>
           </a:p>
         </p:txBody>
       </p:sp>
@@ -3723,8 +5353,8 @@
         </p:nvSpPr>
         <p:spPr>
           <a:xfrm>
-            <a:off x="457200" y="274320"/>
-            <a:ext cx="8229600" cy="868680"/>
+            <a:off x="548640" y="274320"/>
+            <a:ext cx="8046720" cy="868680"/>
           </a:xfrm>
           <a:prstGeom prst="rect">
             <a:avLst/>
@@ -3742,52 +5372,92 @@
             <a:r>
               <a:rPr lang="en-US" sz="2800" b="1" dirty="0">
                 <a:solidFill>
-                  <a:srgbClr val="0F3D3E"/>
+                  <a:srgbClr val="0B2A4A"/>
                 </a:solidFill>
               </a:rPr>
-              <a:t>Công tác sinh viên: đang chờ báo cáo của đơn vị</a:t>
+              <a:t>Lương và phụ cấp chiếm hơn một nửa tổng chi</a:t>
             </a:r>
             <a:endParaRPr lang="en-US" sz="2800" dirty="0"/>
           </a:p>
         </p:txBody>
       </p:sp>
-      <p:sp>
-        <p:nvSpPr>
-          <p:cNvPr id="4" name="cho-bao-cao"/>
+      <p:graphicFrame>
+        <p:nvGraphicFramePr>
+          <p:cNvPr id="4" name="bieu-do" descr=""/>
+          <p:cNvGraphicFramePr/>
+          <p:nvPr/>
+        </p:nvGraphicFramePr>
+        <p:xfrm>
+          <a:off x="548640" y="1234440"/>
+          <a:ext cx="5394960" cy="3154680"/>
+        </p:xfrm>
+        <a:graphic xmlns:a="http://schemas.openxmlformats.org/drawingml/2006/main">
+          <a:graphicData uri="http://schemas.openxmlformats.org/drawingml/2006/chart">
+            <c:chart xmlns:c="http://schemas.openxmlformats.org/drawingml/2006/chart" r:id="rId1"/>
+          </a:graphicData>
+        </a:graphic>
+      </p:graphicFrame>
+      <p:sp>
+        <p:nvSpPr>
+          <p:cNvPr id="5" name="luu-y"/>
           <p:cNvSpPr/>
           <p:nvPr/>
         </p:nvSpPr>
         <p:spPr>
           <a:xfrm>
-            <a:off x="1371600" y="1737360"/>
-            <a:ext cx="6400800" cy="2011680"/>
+            <a:off x="6172200" y="1325880"/>
+            <a:ext cx="2423160" cy="3017520"/>
           </a:xfrm>
           <a:prstGeom prst="roundRect">
             <a:avLst>
-              <a:gd name="adj" fmla="val 4545"/>
+              <a:gd name="adj" fmla="val 3019"/>
             </a:avLst>
           </a:prstGeom>
           <a:solidFill>
-            <a:srgbClr val="EEF3F2"/>
+            <a:srgbClr val="FBF1E1"/>
           </a:solidFill>
           <a:ln w="12700">
             <a:solidFill>
-              <a:srgbClr val="B8C4C3"/>
+              <a:srgbClr val="B8902B"/>
             </a:solidFill>
             <a:prstDash val="solid"/>
           </a:ln>
         </p:spPr>
       </p:sp>
-      <p:sp>
-        <p:nvSpPr>
-          <p:cNvPr id="5" name="cho-bao-cao-chu"/>
+      <p:pic>
+        <p:nvPicPr>
+          <p:cNvPr id="6" name="bieu-tuong" descr="Biểu tượng">    </p:cNvPr>
+          <p:cNvPicPr>
+            <a:picLocks noChangeAspect="1"/>
+          </p:cNvPicPr>
+          <p:nvPr/>
+        </p:nvPicPr>
+        <p:blipFill>
+          <a:blip r:embed="rId2"/>
+          <a:stretch>
+            <a:fillRect/>
+          </a:stretch>
+        </p:blipFill>
+        <p:spPr>
+          <a:xfrm>
+            <a:off x="6355080" y="1527048"/>
+            <a:ext cx="274320" cy="274320"/>
+          </a:xfrm>
+          <a:prstGeom prst="rect">
+            <a:avLst/>
+          </a:prstGeom>
+        </p:spPr>
+      </p:pic>
+      <p:sp>
+        <p:nvSpPr>
+          <p:cNvPr id="7" name="nhan-xet-tieu-de"/>
           <p:cNvSpPr txBox="1"/>
           <p:nvPr/>
         </p:nvSpPr>
         <p:spPr>
           <a:xfrm>
-            <a:off x="1645920" y="1920240"/>
-            <a:ext cx="5852160" cy="1645920"/>
+            <a:off x="6720840" y="1508760"/>
+            <a:ext cx="1691640" cy="329184"/>
           </a:xfrm>
           <a:prstGeom prst="rect">
             <a:avLst/>
@@ -3803,14 +5473,171 @@
               <a:buNone/>
             </a:pPr>
             <a:r>
-              <a:rPr lang="en-US" sz="2000" dirty="0">
-                <a:solidFill>
-                  <a:srgbClr val="1B1F2A"/>
+              <a:rPr lang="en-US" sz="1800" b="1" dirty="0">
+                <a:solidFill>
+                  <a:srgbClr val="A23B3B"/>
                 </a:solidFill>
               </a:rPr>
-              <a:t>Chưa nhận được báo cáo của Phòng Công tác sinh viên. Nội dung sẽ được bổ sung khi có số liệu.</a:t>
-            </a:r>
-            <a:endParaRPr lang="en-US" sz="2000" dirty="0"/>
+              <a:t>Cần rà lại</a:t>
+            </a:r>
+            <a:endParaRPr lang="en-US" sz="1800" dirty="0"/>
+          </a:p>
+        </p:txBody>
+      </p:sp>
+      <p:sp>
+        <p:nvSpPr>
+          <p:cNvPr id="8" name="nhan-xet-chu"/>
+          <p:cNvSpPr txBox="1"/>
+          <p:nvPr/>
+        </p:nvSpPr>
+        <p:spPr>
+          <a:xfrm>
+            <a:off x="6355080" y="1965960"/>
+            <a:ext cx="2057400" cy="2286000"/>
+          </a:xfrm>
+          <a:prstGeom prst="rect">
+            <a:avLst/>
+          </a:prstGeom>
+          <a:noFill/>
+          <a:ln/>
+        </p:spPr>
+        <p:txBody>
+          <a:bodyPr wrap="square" lIns="0" tIns="0" rIns="0" bIns="0" rtlCol="0" anchor="t"/>
+          <a:lstStyle/>
+          <a:p>
+            <a:pPr marL="342900" indent="-342900">
+              <a:spcAft>
+                <a:spcPts val="800"/>
+              </a:spcAft>
+              <a:buSzPct val="100000"/>
+              <a:buChar char="•"/>
+            </a:pPr>
+            <a:r>
+              <a:rPr lang="en-US" sz="1600" dirty="0">
+                <a:solidFill>
+                  <a:srgbClr val="1A2433"/>
+                </a:solidFill>
+              </a:rPr>
+              <a:t>Cộng các nhóm: 398.500</a:t>
+            </a:r>
+            <a:endParaRPr lang="en-US" sz="1600" dirty="0"/>
+          </a:p>
+          <a:p>
+            <a:pPr marL="342900" indent="-342900">
+              <a:spcAft>
+                <a:spcPts val="800"/>
+              </a:spcAft>
+              <a:buSzPct val="100000"/>
+              <a:buChar char="•"/>
+            </a:pPr>
+            <a:r>
+              <a:rPr lang="en-US" sz="1600" dirty="0">
+                <a:solidFill>
+                  <a:srgbClr val="1A2433"/>
+                </a:solidFill>
+              </a:rPr>
+              <a:t>Báo cáo khai: 400.000</a:t>
+            </a:r>
+            <a:endParaRPr lang="en-US" sz="1600" dirty="0"/>
+          </a:p>
+          <a:p>
+            <a:pPr marL="342900" indent="-342900">
+              <a:spcAft>
+                <a:spcPts val="800"/>
+              </a:spcAft>
+              <a:buSzPct val="100000"/>
+              <a:buChar char="•"/>
+            </a:pPr>
+            <a:r>
+              <a:rPr lang="en-US" sz="1600" dirty="0">
+                <a:solidFill>
+                  <a:srgbClr val="1A2433"/>
+                </a:solidFill>
+              </a:rPr>
+              <a:t>Chênh 1.500 triệu đồng chưa giải thích</a:t>
+            </a:r>
+            <a:endParaRPr lang="en-US" sz="1600" dirty="0"/>
+          </a:p>
+        </p:txBody>
+      </p:sp>
+      <p:sp>
+        <p:nvSpPr>
+          <p:cNvPr id="9" name="nguon"/>
+          <p:cNvSpPr txBox="1"/>
+          <p:nvPr/>
+        </p:nvSpPr>
+        <p:spPr>
+          <a:xfrm>
+            <a:off x="548640" y="4416552"/>
+            <a:ext cx="8046720" cy="274320"/>
+          </a:xfrm>
+          <a:prstGeom prst="rect">
+            <a:avLst/>
+          </a:prstGeom>
+          <a:noFill/>
+          <a:ln/>
+        </p:spPr>
+        <p:txBody>
+          <a:bodyPr wrap="square" lIns="0" tIns="0" rIns="0" bIns="0" rtlCol="0" anchor="ctr"/>
+          <a:lstStyle/>
+          <a:p>
+            <a:pPr indent="0" marL="0">
+              <a:buNone/>
+            </a:pPr>
+            <a:r>
+              <a:rPr lang="en-US" sz="1100" i="1" dirty="0">
+                <a:solidFill>
+                  <a:srgbClr val="6B7A90"/>
+                </a:solidFill>
+              </a:rPr>
+              <a:t>Nguồn: báo cáo Phòng Kế hoạch – Tài chính, năm học 2025–2026 (đơn vị: triệu đồng)</a:t>
+            </a:r>
+            <a:endParaRPr lang="en-US" sz="1100" dirty="0"/>
+          </a:p>
+        </p:txBody>
+      </p:sp>
+      <p:sp>
+        <p:nvSpPr>
+          <p:cNvPr id="25" name="Slide Number Placeholder 0"/>
+          <p:cNvSpPr>
+            <a:spLocks noGrp="1"/>
+          </p:cNvSpPr>
+          <p:nvPr>
+            <p:ph type="sldNum" sz="quarter" idx="4294967295"/>
+          </p:nvPr>
+        </p:nvSpPr>
+        <p:spPr>
+          <a:xfrm>
+            <a:off x="8138160" y="4727448"/>
+            <a:ext cx="457200" cy="274320"/>
+          </a:xfrm>
+          <a:prstGeom prst="rect">
+            <a:avLst/>
+          </a:prstGeom>
+          <a:extLst>
+            <a:ext uri="{C572A759-6A51-4108-AA02-DFA0A04FC94B}">
+              <ma14:wrappingTextBoxFlag xmlns:ma14="http://schemas.microsoft.com/office/mac/drawingml/2011/main" val="0"/>
+            </a:ext>
+          </a:extLst>
+        </p:spPr>
+        <p:txBody>
+          <a:bodyPr/>
+          <a:lstStyle>
+            <a:lvl1pPr>
+              <a:defRPr sz="1100">
+                <a:solidFill>
+                  <a:srgbClr val="6B7A90"/>
+                </a:solidFill>
+              </a:defRPr>
+            </a:lvl1pPr>
+          </a:lstStyle>
+          <a:p>
+            <a:pPr algn="r"/>
+            <a:fld id="{F7021451-1387-4CA6-816F-3879F97B5CBC}" type="slidenum">
+              <a:rPr b="0" lang="en-US"/>
+              <a:t>6</a:t>
+            </a:fld>
+            <a:endParaRPr lang="en-US"/>
           </a:p>
         </p:txBody>
       </p:sp>
@@ -3849,8 +5676,8 @@
         </p:nvSpPr>
         <p:spPr>
           <a:xfrm>
-            <a:off x="457200" y="274320"/>
-            <a:ext cx="8229600" cy="868680"/>
+            <a:off x="548640" y="274320"/>
+            <a:ext cx="8046720" cy="868680"/>
           </a:xfrm>
           <a:prstGeom prst="rect">
             <a:avLst/>
@@ -3868,10 +5695,10 @@
             <a:r>
               <a:rPr lang="en-US" sz="2800" b="1" dirty="0">
                 <a:solidFill>
-                  <a:srgbClr val="0F3D3E"/>
+                  <a:srgbClr val="0B2A4A"/>
                 </a:solidFill>
               </a:rPr>
-              <a:t>Ba tồn tại chính cần xử lý năm học tới</a:t>
+              <a:t>Công tác sinh viên: đang chờ báo cáo của đơn vị</a:t>
             </a:r>
             <a:endParaRPr lang="en-US" sz="2800" dirty="0"/>
           </a:p>
@@ -3879,39 +5706,65 @@
       </p:sp>
       <p:sp>
         <p:nvSpPr>
-          <p:cNvPr id="4" name="so-thu-tu"/>
+          <p:cNvPr id="4" name="cho-bao-cao"/>
           <p:cNvSpPr/>
           <p:nvPr/>
         </p:nvSpPr>
         <p:spPr>
           <a:xfrm>
-            <a:off x="457200" y="1417320"/>
-            <a:ext cx="640080" cy="640080"/>
-          </a:xfrm>
-          <a:prstGeom prst="ellipse">
-            <a:avLst/>
+            <a:off x="1097280" y="1463040"/>
+            <a:ext cx="6949440" cy="2377440"/>
+          </a:xfrm>
+          <a:prstGeom prst="roundRect">
+            <a:avLst>
+              <a:gd name="adj" fmla="val 3846"/>
+            </a:avLst>
           </a:prstGeom>
           <a:solidFill>
-            <a:srgbClr val="0F6E6E"/>
+            <a:srgbClr val="F1F4F8"/>
           </a:solidFill>
           <a:ln w="12700">
             <a:solidFill>
-              <a:srgbClr val="0F6E6E"/>
+              <a:srgbClr val="D5DCE6"/>
             </a:solidFill>
             <a:prstDash val="solid"/>
           </a:ln>
         </p:spPr>
       </p:sp>
-      <p:sp>
-        <p:nvSpPr>
-          <p:cNvPr id="5" name="so-thu-tu-chu"/>
+      <p:pic>
+        <p:nvPicPr>
+          <p:cNvPr id="5" name="bieu-tuong" descr="Biểu tượng chờ">    </p:cNvPr>
+          <p:cNvPicPr>
+            <a:picLocks noChangeAspect="1"/>
+          </p:cNvPicPr>
+          <p:nvPr/>
+        </p:nvPicPr>
+        <p:blipFill>
+          <a:blip r:embed="rId1"/>
+          <a:stretch>
+            <a:fillRect/>
+          </a:stretch>
+        </p:blipFill>
+        <p:spPr>
+          <a:xfrm>
+            <a:off x="1463040" y="2331720"/>
+            <a:ext cx="640080" cy="640080"/>
+          </a:xfrm>
+          <a:prstGeom prst="rect">
+            <a:avLst/>
+          </a:prstGeom>
+        </p:spPr>
+      </p:pic>
+      <p:sp>
+        <p:nvSpPr>
+          <p:cNvPr id="6" name="cho-bao-cao-chu"/>
           <p:cNvSpPr txBox="1"/>
           <p:nvPr/>
         </p:nvSpPr>
         <p:spPr>
           <a:xfrm>
-            <a:off x="457200" y="1417320"/>
-            <a:ext cx="640080" cy="640080"/>
+            <a:off x="2377440" y="1737360"/>
+            <a:ext cx="5394960" cy="1828800"/>
           </a:xfrm>
           <a:prstGeom prst="rect">
             <a:avLst/>
@@ -3923,127 +5776,16 @@
           <a:bodyPr wrap="square" lIns="0" tIns="0" rIns="0" bIns="0" rtlCol="0" anchor="ctr"/>
           <a:lstStyle/>
           <a:p>
-            <a:pPr algn="ctr" indent="0" marL="0">
-              <a:buNone/>
-            </a:pPr>
-            <a:r>
-              <a:rPr lang="en-US" sz="2000" b="1" dirty="0">
-                <a:solidFill>
-                  <a:srgbClr val="FFFFFF"/>
-                </a:solidFill>
-              </a:rPr>
-              <a:t>1</a:t>
-            </a:r>
-            <a:endParaRPr lang="en-US" sz="2000" dirty="0"/>
-          </a:p>
-        </p:txBody>
-      </p:sp>
-      <p:sp>
-        <p:nvSpPr>
-          <p:cNvPr id="6" name="ton-tai"/>
-          <p:cNvSpPr txBox="1"/>
-          <p:nvPr/>
-        </p:nvSpPr>
-        <p:spPr>
-          <a:xfrm>
-            <a:off x="1325880" y="1325880"/>
-            <a:ext cx="7315200" cy="914400"/>
-          </a:xfrm>
-          <a:prstGeom prst="rect">
-            <a:avLst/>
-          </a:prstGeom>
-          <a:noFill/>
-          <a:ln/>
-        </p:spPr>
-        <p:txBody>
-          <a:bodyPr wrap="square" lIns="0" tIns="0" rIns="0" bIns="0" rtlCol="0" anchor="ctr"/>
-          <a:lstStyle/>
-          <a:p>
             <a:pPr indent="0" marL="0">
               <a:buNone/>
             </a:pPr>
             <a:r>
-              <a:rPr lang="en-US" sz="1800" b="1" dirty="0">
-                <a:solidFill>
-                  <a:srgbClr val="1B1F2A"/>
+              <a:rPr lang="en-US" sz="2000" dirty="0">
+                <a:solidFill>
+                  <a:srgbClr val="1A2433"/>
                 </a:solidFill>
               </a:rPr>
-              <a:t>Cơ sở vật chất giảng đường chưa đáp ứng giờ cao điểm</a:t>
-            </a:r>
-            <a:endParaRPr lang="en-US" sz="1800" dirty="0"/>
-          </a:p>
-          <a:p>
-            <a:pPr indent="0" marL="0">
-              <a:buNone/>
-            </a:pPr>
-            <a:r>
-              <a:rPr lang="en-US" sz="1400" dirty="0">
-                <a:solidFill>
-                  <a:srgbClr val="4A5656"/>
-                </a:solidFill>
-              </a:rPr>
-              <a:t>Nguyên nhân: Số phòng học không tăng trong khi quy mô tăng</a:t>
-            </a:r>
-            <a:endParaRPr lang="en-US" sz="1800" dirty="0"/>
-          </a:p>
-        </p:txBody>
-      </p:sp>
-      <p:sp>
-        <p:nvSpPr>
-          <p:cNvPr id="7" name="so-thu-tu"/>
-          <p:cNvSpPr/>
-          <p:nvPr/>
-        </p:nvSpPr>
-        <p:spPr>
-          <a:xfrm>
-            <a:off x="457200" y="2496312"/>
-            <a:ext cx="640080" cy="640080"/>
-          </a:xfrm>
-          <a:prstGeom prst="ellipse">
-            <a:avLst/>
-          </a:prstGeom>
-          <a:solidFill>
-            <a:srgbClr val="0F6E6E"/>
-          </a:solidFill>
-          <a:ln w="12700">
-            <a:solidFill>
-              <a:srgbClr val="0F6E6E"/>
-            </a:solidFill>
-            <a:prstDash val="solid"/>
-          </a:ln>
-        </p:spPr>
-      </p:sp>
-      <p:sp>
-        <p:nvSpPr>
-          <p:cNvPr id="8" name="so-thu-tu-chu"/>
-          <p:cNvSpPr txBox="1"/>
-          <p:nvPr/>
-        </p:nvSpPr>
-        <p:spPr>
-          <a:xfrm>
-            <a:off x="457200" y="2496312"/>
-            <a:ext cx="640080" cy="640080"/>
-          </a:xfrm>
-          <a:prstGeom prst="rect">
-            <a:avLst/>
-          </a:prstGeom>
-          <a:noFill/>
-          <a:ln/>
-        </p:spPr>
-        <p:txBody>
-          <a:bodyPr wrap="square" lIns="0" tIns="0" rIns="0" bIns="0" rtlCol="0" anchor="ctr"/>
-          <a:lstStyle/>
-          <a:p>
-            <a:pPr algn="ctr" indent="0" marL="0">
-              <a:buNone/>
-            </a:pPr>
-            <a:r>
-              <a:rPr lang="en-US" sz="2000" b="1" dirty="0">
-                <a:solidFill>
-                  <a:srgbClr val="FFFFFF"/>
-                </a:solidFill>
-              </a:rPr>
-              <a:t>2</a:t>
+              <a:t>Chưa nhận được báo cáo của Phòng Công tác sinh viên. Nội dung sẽ được bổ sung khi có số liệu.</a:t>
             </a:r>
             <a:endParaRPr lang="en-US" sz="2000" dirty="0"/>
           </a:p>
@@ -4051,162 +5793,46 @@
       </p:sp>
       <p:sp>
         <p:nvSpPr>
-          <p:cNvPr id="9" name="ton-tai"/>
-          <p:cNvSpPr txBox="1"/>
-          <p:nvPr/>
-        </p:nvSpPr>
-        <p:spPr>
-          <a:xfrm>
-            <a:off x="1325880" y="2404872"/>
-            <a:ext cx="7315200" cy="914400"/>
-          </a:xfrm>
-          <a:prstGeom prst="rect">
-            <a:avLst/>
-          </a:prstGeom>
-          <a:noFill/>
-          <a:ln/>
-        </p:spPr>
-        <p:txBody>
-          <a:bodyPr wrap="square" lIns="0" tIns="0" rIns="0" bIns="0" rtlCol="0" anchor="ctr"/>
-          <a:lstStyle/>
-          <a:p>
-            <a:pPr indent="0" marL="0">
-              <a:buNone/>
-            </a:pPr>
-            <a:r>
-              <a:rPr lang="en-US" sz="1800" b="1" dirty="0">
-                <a:solidFill>
-                  <a:srgbClr val="1B1F2A"/>
-                </a:solidFill>
-              </a:rPr>
-              <a:t>Tỷ lệ nhập học Luật còn thấp</a:t>
-            </a:r>
-            <a:endParaRPr lang="en-US" sz="1800" dirty="0"/>
-          </a:p>
-          <a:p>
-            <a:pPr indent="0" marL="0">
-              <a:buNone/>
-            </a:pPr>
-            <a:r>
-              <a:rPr lang="en-US" sz="1400" dirty="0">
-                <a:solidFill>
-                  <a:srgbClr val="4A5656"/>
-                </a:solidFill>
-              </a:rPr>
-              <a:t>Nguyên nhân: Chưa có kênh tư vấn riêng cho ngành</a:t>
-            </a:r>
-            <a:endParaRPr lang="en-US" sz="1800" dirty="0"/>
-          </a:p>
-        </p:txBody>
-      </p:sp>
-      <p:sp>
-        <p:nvSpPr>
-          <p:cNvPr id="10" name="so-thu-tu"/>
-          <p:cNvSpPr/>
-          <p:nvPr/>
-        </p:nvSpPr>
-        <p:spPr>
-          <a:xfrm>
-            <a:off x="457200" y="3575304"/>
-            <a:ext cx="640080" cy="640080"/>
-          </a:xfrm>
-          <a:prstGeom prst="ellipse">
-            <a:avLst/>
-          </a:prstGeom>
-          <a:solidFill>
-            <a:srgbClr val="0F6E6E"/>
-          </a:solidFill>
-          <a:ln w="12700">
-            <a:solidFill>
-              <a:srgbClr val="0F6E6E"/>
-            </a:solidFill>
-            <a:prstDash val="solid"/>
-          </a:ln>
-        </p:spPr>
-      </p:sp>
-      <p:sp>
-        <p:nvSpPr>
-          <p:cNvPr id="11" name="so-thu-tu-chu"/>
-          <p:cNvSpPr txBox="1"/>
-          <p:nvPr/>
-        </p:nvSpPr>
-        <p:spPr>
-          <a:xfrm>
-            <a:off x="457200" y="3575304"/>
-            <a:ext cx="640080" cy="640080"/>
-          </a:xfrm>
-          <a:prstGeom prst="rect">
-            <a:avLst/>
-          </a:prstGeom>
-          <a:noFill/>
-          <a:ln/>
-        </p:spPr>
-        <p:txBody>
-          <a:bodyPr wrap="square" lIns="0" tIns="0" rIns="0" bIns="0" rtlCol="0" anchor="ctr"/>
-          <a:lstStyle/>
-          <a:p>
-            <a:pPr algn="ctr" indent="0" marL="0">
-              <a:buNone/>
-            </a:pPr>
-            <a:r>
-              <a:rPr lang="en-US" sz="2000" b="1" dirty="0">
-                <a:solidFill>
-                  <a:srgbClr val="FFFFFF"/>
-                </a:solidFill>
-              </a:rPr>
-              <a:t>3</a:t>
-            </a:r>
-            <a:endParaRPr lang="en-US" sz="2000" dirty="0"/>
-          </a:p>
-        </p:txBody>
-      </p:sp>
-      <p:sp>
-        <p:nvSpPr>
-          <p:cNvPr id="12" name="ton-tai"/>
-          <p:cNvSpPr txBox="1"/>
-          <p:nvPr/>
-        </p:nvSpPr>
-        <p:spPr>
-          <a:xfrm>
-            <a:off x="1325880" y="3483864"/>
-            <a:ext cx="7315200" cy="914400"/>
-          </a:xfrm>
-          <a:prstGeom prst="rect">
-            <a:avLst/>
-          </a:prstGeom>
-          <a:noFill/>
-          <a:ln/>
-        </p:spPr>
-        <p:txBody>
-          <a:bodyPr wrap="square" lIns="0" tIns="0" rIns="0" bIns="0" rtlCol="0" anchor="ctr"/>
-          <a:lstStyle/>
-          <a:p>
-            <a:pPr indent="0" marL="0">
-              <a:buNone/>
-            </a:pPr>
-            <a:r>
-              <a:rPr lang="en-US" sz="1800" b="1" dirty="0">
-                <a:solidFill>
-                  <a:srgbClr val="1B1F2A"/>
-                </a:solidFill>
-              </a:rPr>
-              <a:t>Báo cáo đơn vị nộp chậm</a:t>
-            </a:r>
-            <a:endParaRPr lang="en-US" sz="1800" dirty="0"/>
-          </a:p>
-          <a:p>
-            <a:pPr indent="0" marL="0">
-              <a:buNone/>
-            </a:pPr>
-            <a:r>
-              <a:rPr lang="en-US" sz="1400" dirty="0">
-                <a:solidFill>
-                  <a:srgbClr val="4A5656"/>
-                </a:solidFill>
-              </a:rPr>
-              <a:t>Nguyên nhân: Chưa có mốc nộp thống nhất</a:t>
-            </a:r>
-            <a:endParaRPr lang="en-US" sz="1800" dirty="0"/>
+          <p:cNvPr id="25" name="Slide Number Placeholder 0"/>
+          <p:cNvSpPr>
+            <a:spLocks noGrp="1"/>
+          </p:cNvSpPr>
+          <p:nvPr>
+            <p:ph type="sldNum" sz="quarter" idx="4294967295"/>
+          </p:nvPr>
+        </p:nvSpPr>
+        <p:spPr>
+          <a:xfrm>
+            <a:off x="8138160" y="4727448"/>
+            <a:ext cx="457200" cy="274320"/>
+          </a:xfrm>
+          <a:prstGeom prst="rect">
+            <a:avLst/>
+          </a:prstGeom>
+          <a:extLst>
+            <a:ext uri="{C572A759-6A51-4108-AA02-DFA0A04FC94B}">
+              <ma14:wrappingTextBoxFlag xmlns:ma14="http://schemas.microsoft.com/office/mac/drawingml/2011/main" val="0"/>
+            </a:ext>
+          </a:extLst>
+        </p:spPr>
+        <p:txBody>
+          <a:bodyPr/>
+          <a:lstStyle>
+            <a:lvl1pPr>
+              <a:defRPr sz="1100">
+                <a:solidFill>
+                  <a:srgbClr val="6B7A90"/>
+                </a:solidFill>
+              </a:defRPr>
+            </a:lvl1pPr>
+          </a:lstStyle>
+          <a:p>
+            <a:pPr algn="r"/>
+            <a:fld id="{F7021451-1387-4CA6-816F-3879F97B5CBC}" type="slidenum">
+              <a:rPr b="0" lang="en-US"/>
+              <a:t>7</a:t>
+            </a:fld>
+            <a:endParaRPr lang="en-US"/>
           </a:p>
         </p:txBody>
       </p:sp>
@@ -4245,8 +5871,8 @@
         </p:nvSpPr>
         <p:spPr>
           <a:xfrm>
-            <a:off x="457200" y="274320"/>
-            <a:ext cx="8229600" cy="868680"/>
+            <a:off x="548640" y="274320"/>
+            <a:ext cx="8046720" cy="868680"/>
           </a:xfrm>
           <a:prstGeom prst="rect">
             <a:avLst/>
@@ -4264,10 +5890,10 @@
             <a:r>
               <a:rPr lang="en-US" sz="2800" b="1" dirty="0">
                 <a:solidFill>
-                  <a:srgbClr val="0F3D3E"/>
+                  <a:srgbClr val="0B2A4A"/>
                 </a:solidFill>
               </a:rPr>
-              <a:t>Phương hướng năm học tới: chờ định hướng của Ban Giám hiệu</a:t>
+              <a:t>Ba tồn tại chính cần xử lý trong năm học tới</a:t>
             </a:r>
             <a:endParaRPr lang="en-US" sz="2800" dirty="0"/>
           </a:p>
@@ -4275,14 +5901,66 @@
       </p:sp>
       <p:sp>
         <p:nvSpPr>
-          <p:cNvPr id="4" name="noi-dung"/>
+          <p:cNvPr id="4" name="the"/>
+          <p:cNvSpPr/>
+          <p:nvPr/>
+        </p:nvSpPr>
+        <p:spPr>
+          <a:xfrm>
+            <a:off x="548640" y="1325880"/>
+            <a:ext cx="8046720" cy="868680"/>
+          </a:xfrm>
+          <a:prstGeom prst="roundRect">
+            <a:avLst>
+              <a:gd name="adj" fmla="val 8421"/>
+            </a:avLst>
+          </a:prstGeom>
+          <a:solidFill>
+            <a:srgbClr val="F1F4F8"/>
+          </a:solidFill>
+          <a:ln w="12700">
+            <a:solidFill>
+              <a:srgbClr val="F1F4F8"/>
+            </a:solidFill>
+            <a:prstDash val="solid"/>
+          </a:ln>
+        </p:spPr>
+      </p:sp>
+      <p:sp>
+        <p:nvSpPr>
+          <p:cNvPr id="5" name="so-thu-tu"/>
+          <p:cNvSpPr/>
+          <p:nvPr/>
+        </p:nvSpPr>
+        <p:spPr>
+          <a:xfrm>
+            <a:off x="777240" y="1463040"/>
+            <a:ext cx="594360" cy="594360"/>
+          </a:xfrm>
+          <a:prstGeom prst="ellipse">
+            <a:avLst/>
+          </a:prstGeom>
+          <a:solidFill>
+            <a:srgbClr val="A23B3B"/>
+          </a:solidFill>
+          <a:ln w="12700">
+            <a:solidFill>
+              <a:srgbClr val="A23B3B"/>
+            </a:solidFill>
+            <a:prstDash val="solid"/>
+          </a:ln>
+        </p:spPr>
+      </p:sp>
+      <p:sp>
+        <p:nvSpPr>
+          <p:cNvPr id="6" name="so-thu-tu-chu"/>
           <p:cNvSpPr txBox="1"/>
           <p:nvPr/>
         </p:nvSpPr>
         <p:spPr>
           <a:xfrm>
-            <a:off x="457200" y="1463040"/>
-            <a:ext cx="8229600" cy="2194560"/>
+            <a:off x="777240" y="1463040"/>
+            <a:ext cx="594360" cy="594360"/>
           </a:xfrm>
           <a:prstGeom prst="rect">
             <a:avLst/>
@@ -4291,43 +5969,401 @@
           <a:ln/>
         </p:spPr>
         <p:txBody>
-          <a:bodyPr wrap="square" lIns="0" tIns="0" rIns="0" bIns="0" rtlCol="0" anchor="t"/>
-          <a:lstStyle/>
-          <a:p>
-            <a:pPr marL="342900" indent="-342900">
-              <a:spcAft>
-                <a:spcPts val="800"/>
-              </a:spcAft>
-              <a:buSzPct val="100000"/>
-              <a:buChar char="•"/>
-            </a:pPr>
-            <a:r>
-              <a:rPr lang="en-US" sz="2000" dirty="0">
-                <a:solidFill>
-                  <a:srgbClr val="1B1F2A"/>
-                </a:solidFill>
+          <a:bodyPr wrap="square" lIns="0" tIns="0" rIns="0" bIns="0" rtlCol="0" anchor="ctr"/>
+          <a:lstStyle/>
+          <a:p>
+            <a:pPr algn="ctr" indent="0" marL="0">
+              <a:buNone/>
+            </a:pPr>
+            <a:r>
+              <a:rPr lang="en-US" sz="2200" b="1" dirty="0">
+                <a:solidFill>
+                  <a:srgbClr val="FFFFFF"/>
+                </a:solidFill>
+                <a:latin typeface="Cambria" pitchFamily="34" charset="0"/>
+                <a:ea typeface="Cambria" pitchFamily="34" charset="-122"/>
+                <a:cs typeface="Cambria" pitchFamily="34" charset="-120"/>
               </a:rPr>
-              <a:t>Giải quyết ba tồn tại ở slide trước</a:t>
-            </a:r>
-            <a:endParaRPr lang="en-US" sz="2000" dirty="0"/>
-          </a:p>
-          <a:p>
-            <a:pPr marL="342900" indent="-342900">
-              <a:spcAft>
-                <a:spcPts val="800"/>
-              </a:spcAft>
-              <a:buSzPct val="100000"/>
-              <a:buChar char="•"/>
-            </a:pPr>
-            <a:r>
-              <a:rPr lang="en-US" sz="2000" dirty="0">
-                <a:solidFill>
-                  <a:srgbClr val="1B1F2A"/>
+              <a:t>1</a:t>
+            </a:r>
+            <a:endParaRPr lang="en-US" sz="2200" dirty="0"/>
+          </a:p>
+        </p:txBody>
+      </p:sp>
+      <p:sp>
+        <p:nvSpPr>
+          <p:cNvPr id="7" name="the-chu"/>
+          <p:cNvSpPr txBox="1"/>
+          <p:nvPr/>
+        </p:nvSpPr>
+        <p:spPr>
+          <a:xfrm>
+            <a:off x="1600200" y="1399032"/>
+            <a:ext cx="6766560" cy="722376"/>
+          </a:xfrm>
+          <a:prstGeom prst="rect">
+            <a:avLst/>
+          </a:prstGeom>
+          <a:noFill/>
+          <a:ln/>
+        </p:spPr>
+        <p:txBody>
+          <a:bodyPr wrap="square" lIns="0" tIns="0" rIns="0" bIns="0" rtlCol="0" anchor="ctr"/>
+          <a:lstStyle/>
+          <a:p>
+            <a:pPr indent="0" marL="0">
+              <a:buNone/>
+            </a:pPr>
+            <a:r>
+              <a:rPr lang="en-US" sz="1800" b="1" dirty="0">
+                <a:solidFill>
+                  <a:srgbClr val="0B2A4A"/>
                 </a:solidFill>
               </a:rPr>
-              <a:t>Chỉ tiêu và giải pháp: chờ định hướng của Ban Giám hiệu</a:t>
-            </a:r>
-            <a:endParaRPr lang="en-US" sz="2000" dirty="0"/>
+              <a:t>Cơ sở vật chất giảng đường chưa đáp ứng giờ cao điểm</a:t>
+            </a:r>
+            <a:endParaRPr lang="en-US" sz="1800" dirty="0"/>
+          </a:p>
+          <a:p>
+            <a:pPr indent="0" marL="0">
+              <a:buNone/>
+            </a:pPr>
+            <a:r>
+              <a:rPr lang="en-US" sz="1400" dirty="0">
+                <a:solidFill>
+                  <a:srgbClr val="46536A"/>
+                </a:solidFill>
+              </a:rPr>
+              <a:t>Nguyên nhân: Số phòng học không tăng trong khi quy mô tăng</a:t>
+            </a:r>
+            <a:endParaRPr lang="en-US" sz="1800" dirty="0"/>
+          </a:p>
+        </p:txBody>
+      </p:sp>
+      <p:sp>
+        <p:nvSpPr>
+          <p:cNvPr id="8" name="the"/>
+          <p:cNvSpPr/>
+          <p:nvPr/>
+        </p:nvSpPr>
+        <p:spPr>
+          <a:xfrm>
+            <a:off x="548640" y="2331720"/>
+            <a:ext cx="8046720" cy="868680"/>
+          </a:xfrm>
+          <a:prstGeom prst="roundRect">
+            <a:avLst>
+              <a:gd name="adj" fmla="val 8421"/>
+            </a:avLst>
+          </a:prstGeom>
+          <a:solidFill>
+            <a:srgbClr val="F1F4F8"/>
+          </a:solidFill>
+          <a:ln w="12700">
+            <a:solidFill>
+              <a:srgbClr val="F1F4F8"/>
+            </a:solidFill>
+            <a:prstDash val="solid"/>
+          </a:ln>
+        </p:spPr>
+      </p:sp>
+      <p:sp>
+        <p:nvSpPr>
+          <p:cNvPr id="9" name="so-thu-tu"/>
+          <p:cNvSpPr/>
+          <p:nvPr/>
+        </p:nvSpPr>
+        <p:spPr>
+          <a:xfrm>
+            <a:off x="777240" y="2468880"/>
+            <a:ext cx="594360" cy="594360"/>
+          </a:xfrm>
+          <a:prstGeom prst="ellipse">
+            <a:avLst/>
+          </a:prstGeom>
+          <a:solidFill>
+            <a:srgbClr val="A23B3B"/>
+          </a:solidFill>
+          <a:ln w="12700">
+            <a:solidFill>
+              <a:srgbClr val="A23B3B"/>
+            </a:solidFill>
+            <a:prstDash val="solid"/>
+          </a:ln>
+        </p:spPr>
+      </p:sp>
+      <p:sp>
+        <p:nvSpPr>
+          <p:cNvPr id="10" name="so-thu-tu-chu"/>
+          <p:cNvSpPr txBox="1"/>
+          <p:nvPr/>
+        </p:nvSpPr>
+        <p:spPr>
+          <a:xfrm>
+            <a:off x="777240" y="2468880"/>
+            <a:ext cx="594360" cy="594360"/>
+          </a:xfrm>
+          <a:prstGeom prst="rect">
+            <a:avLst/>
+          </a:prstGeom>
+          <a:noFill/>
+          <a:ln/>
+        </p:spPr>
+        <p:txBody>
+          <a:bodyPr wrap="square" lIns="0" tIns="0" rIns="0" bIns="0" rtlCol="0" anchor="ctr"/>
+          <a:lstStyle/>
+          <a:p>
+            <a:pPr algn="ctr" indent="0" marL="0">
+              <a:buNone/>
+            </a:pPr>
+            <a:r>
+              <a:rPr lang="en-US" sz="2200" b="1" dirty="0">
+                <a:solidFill>
+                  <a:srgbClr val="FFFFFF"/>
+                </a:solidFill>
+                <a:latin typeface="Cambria" pitchFamily="34" charset="0"/>
+                <a:ea typeface="Cambria" pitchFamily="34" charset="-122"/>
+                <a:cs typeface="Cambria" pitchFamily="34" charset="-120"/>
+              </a:rPr>
+              <a:t>2</a:t>
+            </a:r>
+            <a:endParaRPr lang="en-US" sz="2200" dirty="0"/>
+          </a:p>
+        </p:txBody>
+      </p:sp>
+      <p:sp>
+        <p:nvSpPr>
+          <p:cNvPr id="11" name="the-chu"/>
+          <p:cNvSpPr txBox="1"/>
+          <p:nvPr/>
+        </p:nvSpPr>
+        <p:spPr>
+          <a:xfrm>
+            <a:off x="1600200" y="2404872"/>
+            <a:ext cx="6766560" cy="722376"/>
+          </a:xfrm>
+          <a:prstGeom prst="rect">
+            <a:avLst/>
+          </a:prstGeom>
+          <a:noFill/>
+          <a:ln/>
+        </p:spPr>
+        <p:txBody>
+          <a:bodyPr wrap="square" lIns="0" tIns="0" rIns="0" bIns="0" rtlCol="0" anchor="ctr"/>
+          <a:lstStyle/>
+          <a:p>
+            <a:pPr indent="0" marL="0">
+              <a:buNone/>
+            </a:pPr>
+            <a:r>
+              <a:rPr lang="en-US" sz="1800" b="1" dirty="0">
+                <a:solidFill>
+                  <a:srgbClr val="0B2A4A"/>
+                </a:solidFill>
+              </a:rPr>
+              <a:t>Tỷ lệ nhập học Luật còn thấp</a:t>
+            </a:r>
+            <a:endParaRPr lang="en-US" sz="1800" dirty="0"/>
+          </a:p>
+          <a:p>
+            <a:pPr indent="0" marL="0">
+              <a:buNone/>
+            </a:pPr>
+            <a:r>
+              <a:rPr lang="en-US" sz="1400" dirty="0">
+                <a:solidFill>
+                  <a:srgbClr val="46536A"/>
+                </a:solidFill>
+              </a:rPr>
+              <a:t>Nguyên nhân: Chưa có kênh tư vấn riêng cho ngành</a:t>
+            </a:r>
+            <a:endParaRPr lang="en-US" sz="1800" dirty="0"/>
+          </a:p>
+        </p:txBody>
+      </p:sp>
+      <p:sp>
+        <p:nvSpPr>
+          <p:cNvPr id="12" name="the"/>
+          <p:cNvSpPr/>
+          <p:nvPr/>
+        </p:nvSpPr>
+        <p:spPr>
+          <a:xfrm>
+            <a:off x="548640" y="3337560"/>
+            <a:ext cx="8046720" cy="868680"/>
+          </a:xfrm>
+          <a:prstGeom prst="roundRect">
+            <a:avLst>
+              <a:gd name="adj" fmla="val 8421"/>
+            </a:avLst>
+          </a:prstGeom>
+          <a:solidFill>
+            <a:srgbClr val="F1F4F8"/>
+          </a:solidFill>
+          <a:ln w="12700">
+            <a:solidFill>
+              <a:srgbClr val="F1F4F8"/>
+            </a:solidFill>
+            <a:prstDash val="solid"/>
+          </a:ln>
+        </p:spPr>
+      </p:sp>
+      <p:sp>
+        <p:nvSpPr>
+          <p:cNvPr id="13" name="so-thu-tu"/>
+          <p:cNvSpPr/>
+          <p:nvPr/>
+        </p:nvSpPr>
+        <p:spPr>
+          <a:xfrm>
+            <a:off x="777240" y="3474720"/>
+            <a:ext cx="594360" cy="594360"/>
+          </a:xfrm>
+          <a:prstGeom prst="ellipse">
+            <a:avLst/>
+          </a:prstGeom>
+          <a:solidFill>
+            <a:srgbClr val="A23B3B"/>
+          </a:solidFill>
+          <a:ln w="12700">
+            <a:solidFill>
+              <a:srgbClr val="A23B3B"/>
+            </a:solidFill>
+            <a:prstDash val="solid"/>
+          </a:ln>
+        </p:spPr>
+      </p:sp>
+      <p:sp>
+        <p:nvSpPr>
+          <p:cNvPr id="14" name="so-thu-tu-chu"/>
+          <p:cNvSpPr txBox="1"/>
+          <p:nvPr/>
+        </p:nvSpPr>
+        <p:spPr>
+          <a:xfrm>
+            <a:off x="777240" y="3474720"/>
+            <a:ext cx="594360" cy="594360"/>
+          </a:xfrm>
+          <a:prstGeom prst="rect">
+            <a:avLst/>
+          </a:prstGeom>
+          <a:noFill/>
+          <a:ln/>
+        </p:spPr>
+        <p:txBody>
+          <a:bodyPr wrap="square" lIns="0" tIns="0" rIns="0" bIns="0" rtlCol="0" anchor="ctr"/>
+          <a:lstStyle/>
+          <a:p>
+            <a:pPr algn="ctr" indent="0" marL="0">
+              <a:buNone/>
+            </a:pPr>
+            <a:r>
+              <a:rPr lang="en-US" sz="2200" b="1" dirty="0">
+                <a:solidFill>
+                  <a:srgbClr val="FFFFFF"/>
+                </a:solidFill>
+                <a:latin typeface="Cambria" pitchFamily="34" charset="0"/>
+                <a:ea typeface="Cambria" pitchFamily="34" charset="-122"/>
+                <a:cs typeface="Cambria" pitchFamily="34" charset="-120"/>
+              </a:rPr>
+              <a:t>3</a:t>
+            </a:r>
+            <a:endParaRPr lang="en-US" sz="2200" dirty="0"/>
+          </a:p>
+        </p:txBody>
+      </p:sp>
+      <p:sp>
+        <p:nvSpPr>
+          <p:cNvPr id="15" name="the-chu"/>
+          <p:cNvSpPr txBox="1"/>
+          <p:nvPr/>
+        </p:nvSpPr>
+        <p:spPr>
+          <a:xfrm>
+            <a:off x="1600200" y="3410712"/>
+            <a:ext cx="6766560" cy="722376"/>
+          </a:xfrm>
+          <a:prstGeom prst="rect">
+            <a:avLst/>
+          </a:prstGeom>
+          <a:noFill/>
+          <a:ln/>
+        </p:spPr>
+        <p:txBody>
+          <a:bodyPr wrap="square" lIns="0" tIns="0" rIns="0" bIns="0" rtlCol="0" anchor="ctr"/>
+          <a:lstStyle/>
+          <a:p>
+            <a:pPr indent="0" marL="0">
+              <a:buNone/>
+            </a:pPr>
+            <a:r>
+              <a:rPr lang="en-US" sz="1800" b="1" dirty="0">
+                <a:solidFill>
+                  <a:srgbClr val="0B2A4A"/>
+                </a:solidFill>
+              </a:rPr>
+              <a:t>Báo cáo đơn vị nộp chậm</a:t>
+            </a:r>
+            <a:endParaRPr lang="en-US" sz="1800" dirty="0"/>
+          </a:p>
+          <a:p>
+            <a:pPr indent="0" marL="0">
+              <a:buNone/>
+            </a:pPr>
+            <a:r>
+              <a:rPr lang="en-US" sz="1400" dirty="0">
+                <a:solidFill>
+                  <a:srgbClr val="46536A"/>
+                </a:solidFill>
+              </a:rPr>
+              <a:t>Nguyên nhân: Chưa có mốc nộp thống nhất</a:t>
+            </a:r>
+            <a:endParaRPr lang="en-US" sz="1800" dirty="0"/>
+          </a:p>
+        </p:txBody>
+      </p:sp>
+      <p:sp>
+        <p:nvSpPr>
+          <p:cNvPr id="25" name="Slide Number Placeholder 0"/>
+          <p:cNvSpPr>
+            <a:spLocks noGrp="1"/>
+          </p:cNvSpPr>
+          <p:nvPr>
+            <p:ph type="sldNum" sz="quarter" idx="4294967295"/>
+          </p:nvPr>
+        </p:nvSpPr>
+        <p:spPr>
+          <a:xfrm>
+            <a:off x="8138160" y="4727448"/>
+            <a:ext cx="457200" cy="274320"/>
+          </a:xfrm>
+          <a:prstGeom prst="rect">
+            <a:avLst/>
+          </a:prstGeom>
+          <a:extLst>
+            <a:ext uri="{C572A759-6A51-4108-AA02-DFA0A04FC94B}">
+              <ma14:wrappingTextBoxFlag xmlns:ma14="http://schemas.microsoft.com/office/mac/drawingml/2011/main" val="0"/>
+            </a:ext>
+          </a:extLst>
+        </p:spPr>
+        <p:txBody>
+          <a:bodyPr/>
+          <a:lstStyle>
+            <a:lvl1pPr>
+              <a:defRPr sz="1100">
+                <a:solidFill>
+                  <a:srgbClr val="6B7A90"/>
+                </a:solidFill>
+              </a:defRPr>
+            </a:lvl1pPr>
+          </a:lstStyle>
+          <a:p>
+            <a:pPr algn="r"/>
+            <a:fld id="{F7021451-1387-4CA6-816F-3879F97B5CBC}" type="slidenum">
+              <a:rPr b="0" lang="en-US"/>
+              <a:t>8</a:t>
+            </a:fld>
+            <a:endParaRPr lang="en-US"/>
           </a:p>
         </p:txBody>
       </p:sp>
@@ -4366,8 +6402,8 @@
         </p:nvSpPr>
         <p:spPr>
           <a:xfrm>
-            <a:off x="548640" y="1371600"/>
-            <a:ext cx="8046720" cy="1371600"/>
+            <a:off x="548640" y="274320"/>
+            <a:ext cx="8046720" cy="868680"/>
           </a:xfrm>
           <a:prstGeom prst="rect">
             <a:avLst/>
@@ -4376,36 +6412,85 @@
           <a:ln/>
         </p:spPr>
         <p:txBody>
-          <a:bodyPr wrap="square" lIns="0" tIns="0" rIns="0" bIns="0" rtlCol="0" anchor="b"/>
+          <a:bodyPr wrap="square" lIns="0" tIns="0" rIns="0" bIns="0" rtlCol="0" anchor="ctr"/>
           <a:lstStyle/>
           <a:p>
             <a:pPr algn="l" indent="0" marL="0">
               <a:buNone/>
             </a:pPr>
             <a:r>
-              <a:rPr lang="en-US" sz="3600" b="1" dirty="0">
-                <a:solidFill>
-                  <a:srgbClr val="FFFFFF"/>
+              <a:rPr lang="en-US" sz="2800" b="1" dirty="0">
+                <a:solidFill>
+                  <a:srgbClr val="0B2A4A"/>
                 </a:solidFill>
               </a:rPr>
-              <a:t>Trân trọng cảm ơn</a:t>
-            </a:r>
-            <a:endParaRPr lang="en-US" sz="3600" dirty="0"/>
-          </a:p>
-        </p:txBody>
-      </p:sp>
-      <p:sp>
-        <p:nvSpPr>
-          <p:cNvPr id="3" name="Text 0"/>
+              <a:t>Phương hướng năm học tới: chờ định hướng của Ban Giám hiệu</a:t>
+            </a:r>
+            <a:endParaRPr lang="en-US" sz="2800" dirty="0"/>
+          </a:p>
+        </p:txBody>
+      </p:sp>
+      <p:sp>
+        <p:nvSpPr>
+          <p:cNvPr id="4" name="nhan-xet"/>
           <p:cNvSpPr/>
-          <p:nvPr>
-            <p:ph idx="101" type="body" hasCustomPrompt="1"/>
-          </p:nvPr>
-        </p:nvSpPr>
-        <p:spPr>
-          <a:xfrm>
-            <a:off x="548640" y="2926080"/>
-            <a:ext cx="8046720" cy="914400"/>
+          <p:nvPr/>
+        </p:nvSpPr>
+        <p:spPr>
+          <a:xfrm>
+            <a:off x="548640" y="1463040"/>
+            <a:ext cx="3840480" cy="2377440"/>
+          </a:xfrm>
+          <a:prstGeom prst="roundRect">
+            <a:avLst>
+              <a:gd name="adj" fmla="val 3077"/>
+            </a:avLst>
+          </a:prstGeom>
+          <a:solidFill>
+            <a:srgbClr val="F1F4F8"/>
+          </a:solidFill>
+          <a:ln w="12700">
+            <a:solidFill>
+              <a:srgbClr val="F1F4F8"/>
+            </a:solidFill>
+            <a:prstDash val="solid"/>
+          </a:ln>
+        </p:spPr>
+      </p:sp>
+      <p:pic>
+        <p:nvPicPr>
+          <p:cNvPr id="5" name="bieu-tuong" descr="Biểu tượng">    </p:cNvPr>
+          <p:cNvPicPr>
+            <a:picLocks noChangeAspect="1"/>
+          </p:cNvPicPr>
+          <p:nvPr/>
+        </p:nvPicPr>
+        <p:blipFill>
+          <a:blip r:embed="rId1"/>
+          <a:stretch>
+            <a:fillRect/>
+          </a:stretch>
+        </p:blipFill>
+        <p:spPr>
+          <a:xfrm>
+            <a:off x="731520" y="1664208"/>
+            <a:ext cx="274320" cy="274320"/>
+          </a:xfrm>
+          <a:prstGeom prst="rect">
+            <a:avLst/>
+          </a:prstGeom>
+        </p:spPr>
+      </p:pic>
+      <p:sp>
+        <p:nvSpPr>
+          <p:cNvPr id="6" name="nhan-xet-tieu-de"/>
+          <p:cNvSpPr txBox="1"/>
+          <p:nvPr/>
+        </p:nvSpPr>
+        <p:spPr>
+          <a:xfrm>
+            <a:off x="1097280" y="1645920"/>
+            <a:ext cx="3108960" cy="329184"/>
           </a:xfrm>
           <a:prstGeom prst="rect">
             <a:avLst/>
@@ -4414,21 +6499,269 @@
           <a:ln/>
         </p:spPr>
         <p:txBody>
+          <a:bodyPr wrap="square" lIns="0" tIns="0" rIns="0" bIns="0" rtlCol="0" anchor="ctr"/>
+          <a:lstStyle/>
+          <a:p>
+            <a:pPr indent="0" marL="0">
+              <a:buNone/>
+            </a:pPr>
+            <a:r>
+              <a:rPr lang="en-US" sz="1800" b="1" dirty="0">
+                <a:solidFill>
+                  <a:srgbClr val="0B2A4A"/>
+                </a:solidFill>
+              </a:rPr>
+              <a:t>Đã rõ</a:t>
+            </a:r>
+            <a:endParaRPr lang="en-US" sz="1800" dirty="0"/>
+          </a:p>
+        </p:txBody>
+      </p:sp>
+      <p:sp>
+        <p:nvSpPr>
+          <p:cNvPr id="7" name="nhan-xet-chu"/>
+          <p:cNvSpPr txBox="1"/>
+          <p:nvPr/>
+        </p:nvSpPr>
+        <p:spPr>
+          <a:xfrm>
+            <a:off x="731520" y="2103120"/>
+            <a:ext cx="3474720" cy="1645920"/>
+          </a:xfrm>
+          <a:prstGeom prst="rect">
+            <a:avLst/>
+          </a:prstGeom>
+          <a:noFill/>
+          <a:ln/>
+        </p:spPr>
+        <p:txBody>
           <a:bodyPr wrap="square" lIns="0" tIns="0" rIns="0" bIns="0" rtlCol="0" anchor="t"/>
           <a:lstStyle/>
           <a:p>
-            <a:pPr algn="l" indent="0" marL="0">
+            <a:pPr marL="342900" indent="-342900">
+              <a:spcAft>
+                <a:spcPts val="800"/>
+              </a:spcAft>
+              <a:buSzPct val="100000"/>
+              <a:buChar char="•"/>
+            </a:pPr>
+            <a:r>
+              <a:rPr lang="en-US" sz="1600" dirty="0">
+                <a:solidFill>
+                  <a:srgbClr val="1A2433"/>
+                </a:solidFill>
+              </a:rPr>
+              <a:t>Xử lý ba tồn tại ở slide trước</a:t>
+            </a:r>
+            <a:endParaRPr lang="en-US" sz="1600" dirty="0"/>
+          </a:p>
+          <a:p>
+            <a:pPr marL="342900" indent="-342900">
+              <a:spcAft>
+                <a:spcPts val="800"/>
+              </a:spcAft>
+              <a:buSzPct val="100000"/>
+              <a:buChar char="•"/>
+            </a:pPr>
+            <a:r>
+              <a:rPr lang="en-US" sz="1600" dirty="0">
+                <a:solidFill>
+                  <a:srgbClr val="1A2433"/>
+                </a:solidFill>
+              </a:rPr>
+              <a:t>Rà lại số liệu chi và bổ sung báo cáo công tác sinh viên</a:t>
+            </a:r>
+            <a:endParaRPr lang="en-US" sz="1600" dirty="0"/>
+          </a:p>
+        </p:txBody>
+      </p:sp>
+      <p:sp>
+        <p:nvSpPr>
+          <p:cNvPr id="8" name="luu-y"/>
+          <p:cNvSpPr/>
+          <p:nvPr/>
+        </p:nvSpPr>
+        <p:spPr>
+          <a:xfrm>
+            <a:off x="4754880" y="1463040"/>
+            <a:ext cx="3840480" cy="2377440"/>
+          </a:xfrm>
+          <a:prstGeom prst="roundRect">
+            <a:avLst>
+              <a:gd name="adj" fmla="val 3077"/>
+            </a:avLst>
+          </a:prstGeom>
+          <a:solidFill>
+            <a:srgbClr val="FBF1E1"/>
+          </a:solidFill>
+          <a:ln w="12700">
+            <a:solidFill>
+              <a:srgbClr val="B8902B"/>
+            </a:solidFill>
+            <a:prstDash val="solid"/>
+          </a:ln>
+        </p:spPr>
+      </p:sp>
+      <p:pic>
+        <p:nvPicPr>
+          <p:cNvPr id="9" name="bieu-tuong" descr="Biểu tượng">    </p:cNvPr>
+          <p:cNvPicPr>
+            <a:picLocks noChangeAspect="1"/>
+          </p:cNvPicPr>
+          <p:nvPr/>
+        </p:nvPicPr>
+        <p:blipFill>
+          <a:blip r:embed="rId2"/>
+          <a:stretch>
+            <a:fillRect/>
+          </a:stretch>
+        </p:blipFill>
+        <p:spPr>
+          <a:xfrm>
+            <a:off x="4937760" y="1664208"/>
+            <a:ext cx="274320" cy="274320"/>
+          </a:xfrm>
+          <a:prstGeom prst="rect">
+            <a:avLst/>
+          </a:prstGeom>
+        </p:spPr>
+      </p:pic>
+      <p:sp>
+        <p:nvSpPr>
+          <p:cNvPr id="10" name="nhan-xet-tieu-de"/>
+          <p:cNvSpPr txBox="1"/>
+          <p:nvPr/>
+        </p:nvSpPr>
+        <p:spPr>
+          <a:xfrm>
+            <a:off x="5303520" y="1645920"/>
+            <a:ext cx="3108960" cy="329184"/>
+          </a:xfrm>
+          <a:prstGeom prst="rect">
+            <a:avLst/>
+          </a:prstGeom>
+          <a:noFill/>
+          <a:ln/>
+        </p:spPr>
+        <p:txBody>
+          <a:bodyPr wrap="square" lIns="0" tIns="0" rIns="0" bIns="0" rtlCol="0" anchor="ctr"/>
+          <a:lstStyle/>
+          <a:p>
+            <a:pPr indent="0" marL="0">
               <a:buNone/>
             </a:pPr>
             <a:r>
-              <a:rPr lang="en-US" sz="1800" dirty="0">
-                <a:solidFill>
-                  <a:srgbClr val="CFE3E1"/>
+              <a:rPr lang="en-US" sz="1800" b="1" dirty="0">
+                <a:solidFill>
+                  <a:srgbClr val="A23B3B"/>
                 </a:solidFill>
               </a:rPr>
-              <a:t>Trao đổi và góp ý</a:t>
+              <a:t>Chờ chỉ đạo</a:t>
             </a:r>
             <a:endParaRPr lang="en-US" sz="1800" dirty="0"/>
+          </a:p>
+        </p:txBody>
+      </p:sp>
+      <p:sp>
+        <p:nvSpPr>
+          <p:cNvPr id="11" name="nhan-xet-chu"/>
+          <p:cNvSpPr txBox="1"/>
+          <p:nvPr/>
+        </p:nvSpPr>
+        <p:spPr>
+          <a:xfrm>
+            <a:off x="4937760" y="2103120"/>
+            <a:ext cx="3474720" cy="1645920"/>
+          </a:xfrm>
+          <a:prstGeom prst="rect">
+            <a:avLst/>
+          </a:prstGeom>
+          <a:noFill/>
+          <a:ln/>
+        </p:spPr>
+        <p:txBody>
+          <a:bodyPr wrap="square" lIns="0" tIns="0" rIns="0" bIns="0" rtlCol="0" anchor="t"/>
+          <a:lstStyle/>
+          <a:p>
+            <a:pPr marL="342900" indent="-342900">
+              <a:spcAft>
+                <a:spcPts val="800"/>
+              </a:spcAft>
+              <a:buSzPct val="100000"/>
+              <a:buChar char="•"/>
+            </a:pPr>
+            <a:r>
+              <a:rPr lang="en-US" sz="1600" dirty="0">
+                <a:solidFill>
+                  <a:srgbClr val="1A2433"/>
+                </a:solidFill>
+              </a:rPr>
+              <a:t>Chỉ tiêu năm học mới: chờ định hướng của Ban Giám hiệu</a:t>
+            </a:r>
+            <a:endParaRPr lang="en-US" sz="1600" dirty="0"/>
+          </a:p>
+          <a:p>
+            <a:pPr marL="342900" indent="-342900">
+              <a:spcAft>
+                <a:spcPts val="800"/>
+              </a:spcAft>
+              <a:buSzPct val="100000"/>
+              <a:buChar char="•"/>
+            </a:pPr>
+            <a:r>
+              <a:rPr lang="en-US" sz="1600" dirty="0">
+                <a:solidFill>
+                  <a:srgbClr val="1A2433"/>
+                </a:solidFill>
+              </a:rPr>
+              <a:t>Giải pháp trọng tâm: chờ định hướng của Ban Giám hiệu</a:t>
+            </a:r>
+            <a:endParaRPr lang="en-US" sz="1600" dirty="0"/>
+          </a:p>
+        </p:txBody>
+      </p:sp>
+      <p:sp>
+        <p:nvSpPr>
+          <p:cNvPr id="25" name="Slide Number Placeholder 0"/>
+          <p:cNvSpPr>
+            <a:spLocks noGrp="1"/>
+          </p:cNvSpPr>
+          <p:nvPr>
+            <p:ph type="sldNum" sz="quarter" idx="4294967295"/>
+          </p:nvPr>
+        </p:nvSpPr>
+        <p:spPr>
+          <a:xfrm>
+            <a:off x="8138160" y="4727448"/>
+            <a:ext cx="457200" cy="274320"/>
+          </a:xfrm>
+          <a:prstGeom prst="rect">
+            <a:avLst/>
+          </a:prstGeom>
+          <a:extLst>
+            <a:ext uri="{C572A759-6A51-4108-AA02-DFA0A04FC94B}">
+              <ma14:wrappingTextBoxFlag xmlns:ma14="http://schemas.microsoft.com/office/mac/drawingml/2011/main" val="0"/>
+            </a:ext>
+          </a:extLst>
+        </p:spPr>
+        <p:txBody>
+          <a:bodyPr/>
+          <a:lstStyle>
+            <a:lvl1pPr>
+              <a:defRPr sz="1100">
+                <a:solidFill>
+                  <a:srgbClr val="6B7A90"/>
+                </a:solidFill>
+              </a:defRPr>
+            </a:lvl1pPr>
+          </a:lstStyle>
+          <a:p>
+            <a:pPr algn="r"/>
+            <a:fld id="{F7021451-1387-4CA6-816F-3879F97B5CBC}" type="slidenum">
+              <a:rPr b="0" lang="en-US"/>
+              <a:t>9</a:t>
+            </a:fld>
+            <a:endParaRPr lang="en-US"/>
           </a:p>
         </p:txBody>
       </p:sp>
@@ -4441,47 +6774,47 @@
 </file>
 
 <file path=ppt/theme/theme1.xml><?xml version="1.0" encoding="utf-8"?>
-<a:theme xmlns:a="http://schemas.openxmlformats.org/drawingml/2006/main" name="Thu nghiem">
+<a:theme xmlns:a="http://schemas.openxmlformats.org/drawingml/2006/main" name="Dai hoc">
   <a:themeElements>
-    <a:clrScheme name="Thu nghiem">
+    <a:clrScheme name="Dai hoc">
       <a:dk1>
-        <a:srgbClr val="1B1F2A"/>
+        <a:srgbClr val="1A2433"/>
       </a:dk1>
       <a:lt1>
         <a:srgbClr val="FFFFFF"/>
       </a:lt1>
       <a:dk2>
-        <a:srgbClr val="0F3D3E"/>
+        <a:srgbClr val="0B2A4A"/>
       </a:dk2>
       <a:lt2>
-        <a:srgbClr val="EEF3F2"/>
+        <a:srgbClr val="F1F4F8"/>
       </a:lt2>
       <a:accent1>
-        <a:srgbClr val="0F6E6E"/>
+        <a:srgbClr val="1F4E8C"/>
       </a:accent1>
       <a:accent2>
-        <a:srgbClr val="D9822B"/>
+        <a:srgbClr val="B8902B"/>
       </a:accent2>
       <a:accent3>
-        <a:srgbClr val="5B8DB8"/>
+        <a:srgbClr val="2E7D6B"/>
       </a:accent3>
       <a:accent4>
-        <a:srgbClr val="7A8B8B"/>
+        <a:srgbClr val="6B7A90"/>
       </a:accent4>
       <a:accent5>
-        <a:srgbClr val="B5473A"/>
+        <a:srgbClr val="A23B3B"/>
       </a:accent5>
       <a:accent6>
-        <a:srgbClr val="3E7C4F"/>
+        <a:srgbClr val="5B8DB8"/>
       </a:accent6>
       <a:hlink>
-        <a:srgbClr val="0F6E6E"/>
+        <a:srgbClr val="1F4E8C"/>
       </a:hlink>
       <a:folHlink>
-        <a:srgbClr val="7A8B8B"/>
+        <a:srgbClr val="6B7A90"/>
       </a:folHlink>
     </a:clrScheme>
-    <a:fontScheme name="Thu nghiem">
+    <a:fontScheme name="Dai hoc">
       <a:majorFont>
         <a:latin typeface="Cambria"/>
         <a:ea typeface=""/>

</xml_diff>